<commit_message>
Add themed animations: galloping horse, sword clash, arrow volley, spinning coin, rising Qutb Minar
Co-authored-by: arena-agent <297053741+arena-agent@users.noreply.github.com>
</commit_message>
<xml_diff>
--- a/assignment/Slave_Dynasty_Mamluk_Presentation.pptx
+++ b/assignment/Slave_Dynasty_Mamluk_Presentation.pptx
@@ -3534,6 +3534,30 @@
           </a:p>
         </p:txBody>
       </p:sp>
+      <p:pic>
+        <p:nvPicPr>
+          <p:cNvPr id="11" name="Picture 10" descr="horse.png"/>
+          <p:cNvPicPr>
+            <a:picLocks noChangeAspect="1"/>
+          </p:cNvPicPr>
+          <p:nvPr/>
+        </p:nvPicPr>
+        <p:blipFill>
+          <a:blip r:embed="rId5"/>
+          <a:stretch>
+            <a:fillRect/>
+          </a:stretch>
+        </p:blipFill>
+        <p:spPr>
+          <a:xfrm>
+            <a:off x="-1700784" y="5577840"/>
+            <a:ext cx="1417320" cy="1096217"/>
+          </a:xfrm>
+          <a:prstGeom prst="rect">
+            <a:avLst/>
+          </a:prstGeom>
+        </p:spPr>
+      </p:pic>
     </p:spTree>
   </p:cSld>
   <p:clrMapOvr>
@@ -3878,6 +3902,45 @@
                                         </p:tgtEl>
                                       </p:cBhvr>
                                     </p:animEffect>
+                                  </p:childTnLst>
+                                </p:cTn>
+                              </p:par>
+                            </p:childTnLst>
+                          </p:cTn>
+                        </p:par>
+                      </p:childTnLst>
+                    </p:cTn>
+                  </p:par>
+                  <p:par>
+                    <p:cTn id="34" fill="hold">
+                      <p:stCondLst>
+                        <p:cond delay="0"/>
+                      </p:stCondLst>
+                      <p:childTnLst>
+                        <p:par>
+                          <p:cTn id="35" fill="hold">
+                            <p:stCondLst>
+                              <p:cond delay="0"/>
+                            </p:stCondLst>
+                            <p:childTnLst>
+                              <p:par>
+                                <p:cTn id="36" presetID="0" presetClass="path" presetSubtype="0" fill="hold" grpId="0" nodeType="afterEffect">
+                                  <p:stCondLst>
+                                    <p:cond delay="0"/>
+                                  </p:stCondLst>
+                                  <p:childTnLst>
+                                    <p:animMotion origin="layout" path="M 0 0 L 0.1 -0.015 L 0.2 0 L 0.3 -0.015 L 0.4 0 L 0.5 -0.015 L 0.6 0 L 0.7 -0.015 L 0.8 0 L 0.9 -0.015 L 1.0 0 L 1.18 0 E" pathEditMode="relative" ptsTypes="">
+                                      <p:cBhvr>
+                                        <p:cTn id="37" dur="7000" repeatCount="indefinite" fill="hold"/>
+                                        <p:tgtEl>
+                                          <p:spTgt spid="11"/>
+                                        </p:tgtEl>
+                                        <p:attrNameLst>
+                                          <p:attrName>ppt_x</p:attrName>
+                                          <p:attrName>ppt_y</p:attrName>
+                                        </p:attrNameLst>
+                                      </p:cBhvr>
+                                    </p:animMotion>
                                   </p:childTnLst>
                                 </p:cTn>
                               </p:par>
@@ -4515,7 +4578,7 @@
                                 </p:cTn>
                               </p:par>
                               <p:par>
-                                <p:cTn id="14" presetID="53" presetClass="entr" presetSubtype="0" fill="hold" grpId="0" nodeType="withEffect">
+                                <p:cTn id="14" presetID="10" presetClass="entr" presetSubtype="0" fill="hold" grpId="0" nodeType="withEffect">
                                   <p:stCondLst>
                                     <p:cond delay="150"/>
                                   </p:stCondLst>
@@ -4543,77 +4606,6 @@
                                         <p:cTn id="16" dur="600"/>
                                         <p:tgtEl>
                                           <p:spTgt spid="7"/>
-                                        </p:tgtEl>
-                                      </p:cBhvr>
-                                    </p:animEffect>
-                                    <p:animScale>
-                                      <p:cBhvr>
-                                        <p:cTn id="17" dur="600" fill="hold"/>
-                                        <p:tgtEl>
-                                          <p:spTgt spid="7"/>
-                                        </p:tgtEl>
-                                      </p:cBhvr>
-                                      <p:from x="20000" y="20000"/>
-                                      <p:to x="100000" y="100000"/>
-                                    </p:animScale>
-                                  </p:childTnLst>
-                                </p:cTn>
-                              </p:par>
-                            </p:childTnLst>
-                          </p:cTn>
-                        </p:par>
-                      </p:childTnLst>
-                    </p:cTn>
-                  </p:par>
-                  <p:par>
-                    <p:cTn id="18" fill="hold">
-                      <p:stCondLst>
-                        <p:cond delay="indefinite"/>
-                      </p:stCondLst>
-                      <p:childTnLst>
-                        <p:par>
-                          <p:cTn id="19" fill="hold">
-                            <p:stCondLst>
-                              <p:cond delay="0"/>
-                            </p:stCondLst>
-                            <p:childTnLst>
-                              <p:par>
-                                <p:cTn id="20" presetID="10" presetClass="entr" presetSubtype="0" fill="hold" grpId="0" nodeType="clickEffect">
-                                  <p:stCondLst>
-                                    <p:cond delay="0"/>
-                                  </p:stCondLst>
-                                  <p:childTnLst>
-                                    <p:set>
-                                      <p:cBhvr>
-                                        <p:cTn id="21" dur="1" fill="hold">
-                                          <p:stCondLst>
-                                            <p:cond delay="0"/>
-                                          </p:stCondLst>
-                                        </p:cTn>
-                                        <p:tgtEl>
-                                          <p:spTgt spid="8">
-                                            <p:txEl>
-                                              <p:pRg st="0" end="0"/>
-                                            </p:txEl>
-                                          </p:spTgt>
-                                        </p:tgtEl>
-                                        <p:attrNameLst>
-                                          <p:attrName>style.visibility</p:attrName>
-                                        </p:attrNameLst>
-                                      </p:cBhvr>
-                                      <p:to>
-                                        <p:strVal val="visible"/>
-                                      </p:to>
-                                    </p:set>
-                                    <p:animEffect transition="in" filter="fade">
-                                      <p:cBhvr>
-                                        <p:cTn id="22" dur="400"/>
-                                        <p:tgtEl>
-                                          <p:spTgt spid="8">
-                                            <p:txEl>
-                                              <p:pRg st="0" end="0"/>
-                                            </p:txEl>
-                                          </p:spTgt>
                                         </p:tgtEl>
                                       </p:cBhvr>
                                     </p:animEffect>
@@ -4627,26 +4619,26 @@
                     </p:cTn>
                   </p:par>
                   <p:par>
-                    <p:cTn id="23" fill="hold">
+                    <p:cTn id="17" fill="hold">
                       <p:stCondLst>
                         <p:cond delay="indefinite"/>
                       </p:stCondLst>
                       <p:childTnLst>
                         <p:par>
-                          <p:cTn id="24" fill="hold">
+                          <p:cTn id="18" fill="hold">
                             <p:stCondLst>
                               <p:cond delay="0"/>
                             </p:stCondLst>
                             <p:childTnLst>
                               <p:par>
-                                <p:cTn id="25" presetID="10" presetClass="entr" presetSubtype="0" fill="hold" grpId="0" nodeType="clickEffect">
+                                <p:cTn id="19" presetID="10" presetClass="entr" presetSubtype="0" fill="hold" grpId="0" nodeType="clickEffect">
                                   <p:stCondLst>
                                     <p:cond delay="0"/>
                                   </p:stCondLst>
                                   <p:childTnLst>
                                     <p:set>
                                       <p:cBhvr>
-                                        <p:cTn id="26" dur="1" fill="hold">
+                                        <p:cTn id="20" dur="1" fill="hold">
                                           <p:stCondLst>
                                             <p:cond delay="0"/>
                                           </p:stCondLst>
@@ -4654,7 +4646,7 @@
                                         <p:tgtEl>
                                           <p:spTgt spid="8">
                                             <p:txEl>
-                                              <p:pRg st="1" end="1"/>
+                                              <p:pRg st="0" end="0"/>
                                             </p:txEl>
                                           </p:spTgt>
                                         </p:tgtEl>
@@ -4668,11 +4660,11 @@
                                     </p:set>
                                     <p:animEffect transition="in" filter="fade">
                                       <p:cBhvr>
-                                        <p:cTn id="27" dur="400"/>
+                                        <p:cTn id="21" dur="400"/>
                                         <p:tgtEl>
                                           <p:spTgt spid="8">
                                             <p:txEl>
-                                              <p:pRg st="1" end="1"/>
+                                              <p:pRg st="0" end="0"/>
                                             </p:txEl>
                                           </p:spTgt>
                                         </p:tgtEl>
@@ -4688,26 +4680,26 @@
                     </p:cTn>
                   </p:par>
                   <p:par>
-                    <p:cTn id="28" fill="hold">
+                    <p:cTn id="22" fill="hold">
                       <p:stCondLst>
                         <p:cond delay="indefinite"/>
                       </p:stCondLst>
                       <p:childTnLst>
                         <p:par>
-                          <p:cTn id="29" fill="hold">
+                          <p:cTn id="23" fill="hold">
                             <p:stCondLst>
                               <p:cond delay="0"/>
                             </p:stCondLst>
                             <p:childTnLst>
                               <p:par>
-                                <p:cTn id="30" presetID="10" presetClass="entr" presetSubtype="0" fill="hold" grpId="0" nodeType="clickEffect">
+                                <p:cTn id="24" presetID="10" presetClass="entr" presetSubtype="0" fill="hold" grpId="0" nodeType="clickEffect">
                                   <p:stCondLst>
                                     <p:cond delay="0"/>
                                   </p:stCondLst>
                                   <p:childTnLst>
                                     <p:set>
                                       <p:cBhvr>
-                                        <p:cTn id="31" dur="1" fill="hold">
+                                        <p:cTn id="25" dur="1" fill="hold">
                                           <p:stCondLst>
                                             <p:cond delay="0"/>
                                           </p:stCondLst>
@@ -4715,7 +4707,7 @@
                                         <p:tgtEl>
                                           <p:spTgt spid="8">
                                             <p:txEl>
-                                              <p:pRg st="2" end="2"/>
+                                              <p:pRg st="1" end="1"/>
                                             </p:txEl>
                                           </p:spTgt>
                                         </p:tgtEl>
@@ -4729,11 +4721,11 @@
                                     </p:set>
                                     <p:animEffect transition="in" filter="fade">
                                       <p:cBhvr>
-                                        <p:cTn id="32" dur="400"/>
+                                        <p:cTn id="26" dur="400"/>
                                         <p:tgtEl>
                                           <p:spTgt spid="8">
                                             <p:txEl>
-                                              <p:pRg st="2" end="2"/>
+                                              <p:pRg st="1" end="1"/>
                                             </p:txEl>
                                           </p:spTgt>
                                         </p:tgtEl>
@@ -4749,26 +4741,26 @@
                     </p:cTn>
                   </p:par>
                   <p:par>
-                    <p:cTn id="33" fill="hold">
+                    <p:cTn id="27" fill="hold">
                       <p:stCondLst>
                         <p:cond delay="indefinite"/>
                       </p:stCondLst>
                       <p:childTnLst>
                         <p:par>
-                          <p:cTn id="34" fill="hold">
+                          <p:cTn id="28" fill="hold">
                             <p:stCondLst>
                               <p:cond delay="0"/>
                             </p:stCondLst>
                             <p:childTnLst>
                               <p:par>
-                                <p:cTn id="35" presetID="10" presetClass="entr" presetSubtype="0" fill="hold" grpId="0" nodeType="clickEffect">
+                                <p:cTn id="29" presetID="10" presetClass="entr" presetSubtype="0" fill="hold" grpId="0" nodeType="clickEffect">
                                   <p:stCondLst>
                                     <p:cond delay="0"/>
                                   </p:stCondLst>
                                   <p:childTnLst>
                                     <p:set>
                                       <p:cBhvr>
-                                        <p:cTn id="36" dur="1" fill="hold">
+                                        <p:cTn id="30" dur="1" fill="hold">
                                           <p:stCondLst>
                                             <p:cond delay="0"/>
                                           </p:stCondLst>
@@ -4776,7 +4768,7 @@
                                         <p:tgtEl>
                                           <p:spTgt spid="8">
                                             <p:txEl>
-                                              <p:pRg st="3" end="3"/>
+                                              <p:pRg st="2" end="2"/>
                                             </p:txEl>
                                           </p:spTgt>
                                         </p:tgtEl>
@@ -4790,11 +4782,11 @@
                                     </p:set>
                                     <p:animEffect transition="in" filter="fade">
                                       <p:cBhvr>
-                                        <p:cTn id="37" dur="400"/>
+                                        <p:cTn id="31" dur="400"/>
                                         <p:tgtEl>
                                           <p:spTgt spid="8">
                                             <p:txEl>
-                                              <p:pRg st="3" end="3"/>
+                                              <p:pRg st="2" end="2"/>
                                             </p:txEl>
                                           </p:spTgt>
                                         </p:tgtEl>
@@ -4810,26 +4802,26 @@
                     </p:cTn>
                   </p:par>
                   <p:par>
-                    <p:cTn id="38" fill="hold">
+                    <p:cTn id="32" fill="hold">
                       <p:stCondLst>
                         <p:cond delay="indefinite"/>
                       </p:stCondLst>
                       <p:childTnLst>
                         <p:par>
-                          <p:cTn id="39" fill="hold">
+                          <p:cTn id="33" fill="hold">
                             <p:stCondLst>
                               <p:cond delay="0"/>
                             </p:stCondLst>
                             <p:childTnLst>
                               <p:par>
-                                <p:cTn id="40" presetID="10" presetClass="entr" presetSubtype="0" fill="hold" grpId="0" nodeType="clickEffect">
+                                <p:cTn id="34" presetID="10" presetClass="entr" presetSubtype="0" fill="hold" grpId="0" nodeType="clickEffect">
                                   <p:stCondLst>
                                     <p:cond delay="0"/>
                                   </p:stCondLst>
                                   <p:childTnLst>
                                     <p:set>
                                       <p:cBhvr>
-                                        <p:cTn id="41" dur="1" fill="hold">
+                                        <p:cTn id="35" dur="1" fill="hold">
                                           <p:stCondLst>
                                             <p:cond delay="0"/>
                                           </p:stCondLst>
@@ -4837,7 +4829,7 @@
                                         <p:tgtEl>
                                           <p:spTgt spid="8">
                                             <p:txEl>
-                                              <p:pRg st="4" end="4"/>
+                                              <p:pRg st="3" end="3"/>
                                             </p:txEl>
                                           </p:spTgt>
                                         </p:tgtEl>
@@ -4851,11 +4843,11 @@
                                     </p:set>
                                     <p:animEffect transition="in" filter="fade">
                                       <p:cBhvr>
-                                        <p:cTn id="42" dur="400"/>
+                                        <p:cTn id="36" dur="400"/>
                                         <p:tgtEl>
                                           <p:spTgt spid="8">
                                             <p:txEl>
-                                              <p:pRg st="4" end="4"/>
+                                              <p:pRg st="3" end="3"/>
                                             </p:txEl>
                                           </p:spTgt>
                                         </p:tgtEl>
@@ -4871,26 +4863,87 @@
                     </p:cTn>
                   </p:par>
                   <p:par>
-                    <p:cTn id="43" fill="hold">
+                    <p:cTn id="37" fill="hold">
                       <p:stCondLst>
                         <p:cond delay="indefinite"/>
                       </p:stCondLst>
                       <p:childTnLst>
                         <p:par>
-                          <p:cTn id="44" fill="hold">
+                          <p:cTn id="38" fill="hold">
                             <p:stCondLst>
                               <p:cond delay="0"/>
                             </p:stCondLst>
                             <p:childTnLst>
                               <p:par>
-                                <p:cTn id="45" presetID="10" presetClass="entr" presetSubtype="0" fill="hold" grpId="0" nodeType="clickEffect">
+                                <p:cTn id="39" presetID="10" presetClass="entr" presetSubtype="0" fill="hold" grpId="0" nodeType="clickEffect">
                                   <p:stCondLst>
                                     <p:cond delay="0"/>
                                   </p:stCondLst>
                                   <p:childTnLst>
                                     <p:set>
                                       <p:cBhvr>
-                                        <p:cTn id="46" dur="1" fill="hold">
+                                        <p:cTn id="40" dur="1" fill="hold">
+                                          <p:stCondLst>
+                                            <p:cond delay="0"/>
+                                          </p:stCondLst>
+                                        </p:cTn>
+                                        <p:tgtEl>
+                                          <p:spTgt spid="8">
+                                            <p:txEl>
+                                              <p:pRg st="4" end="4"/>
+                                            </p:txEl>
+                                          </p:spTgt>
+                                        </p:tgtEl>
+                                        <p:attrNameLst>
+                                          <p:attrName>style.visibility</p:attrName>
+                                        </p:attrNameLst>
+                                      </p:cBhvr>
+                                      <p:to>
+                                        <p:strVal val="visible"/>
+                                      </p:to>
+                                    </p:set>
+                                    <p:animEffect transition="in" filter="fade">
+                                      <p:cBhvr>
+                                        <p:cTn id="41" dur="400"/>
+                                        <p:tgtEl>
+                                          <p:spTgt spid="8">
+                                            <p:txEl>
+                                              <p:pRg st="4" end="4"/>
+                                            </p:txEl>
+                                          </p:spTgt>
+                                        </p:tgtEl>
+                                      </p:cBhvr>
+                                    </p:animEffect>
+                                  </p:childTnLst>
+                                </p:cTn>
+                              </p:par>
+                            </p:childTnLst>
+                          </p:cTn>
+                        </p:par>
+                      </p:childTnLst>
+                    </p:cTn>
+                  </p:par>
+                  <p:par>
+                    <p:cTn id="42" fill="hold">
+                      <p:stCondLst>
+                        <p:cond delay="indefinite"/>
+                      </p:stCondLst>
+                      <p:childTnLst>
+                        <p:par>
+                          <p:cTn id="43" fill="hold">
+                            <p:stCondLst>
+                              <p:cond delay="0"/>
+                            </p:stCondLst>
+                            <p:childTnLst>
+                              <p:par>
+                                <p:cTn id="44" presetID="10" presetClass="entr" presetSubtype="0" fill="hold" grpId="0" nodeType="clickEffect">
+                                  <p:stCondLst>
+                                    <p:cond delay="0"/>
+                                  </p:stCondLst>
+                                  <p:childTnLst>
+                                    <p:set>
+                                      <p:cBhvr>
+                                        <p:cTn id="45" dur="1" fill="hold">
                                           <p:stCondLst>
                                             <p:cond delay="0"/>
                                           </p:stCondLst>
@@ -4912,7 +4965,7 @@
                                     </p:set>
                                     <p:animEffect transition="in" filter="fade">
                                       <p:cBhvr>
-                                        <p:cTn id="47" dur="400"/>
+                                        <p:cTn id="46" dur="400"/>
                                         <p:tgtEl>
                                           <p:spTgt spid="8">
                                             <p:txEl>
@@ -6327,7 +6380,7 @@
                                 </p:cTn>
                               </p:par>
                               <p:par>
-                                <p:cTn id="14" presetID="53" presetClass="entr" presetSubtype="0" fill="hold" grpId="0" nodeType="withEffect">
+                                <p:cTn id="14" presetID="10" presetClass="entr" presetSubtype="0" fill="hold" grpId="0" nodeType="withEffect">
                                   <p:stCondLst>
                                     <p:cond delay="150"/>
                                   </p:stCondLst>
@@ -6355,77 +6408,6 @@
                                         <p:cTn id="16" dur="600"/>
                                         <p:tgtEl>
                                           <p:spTgt spid="7"/>
-                                        </p:tgtEl>
-                                      </p:cBhvr>
-                                    </p:animEffect>
-                                    <p:animScale>
-                                      <p:cBhvr>
-                                        <p:cTn id="17" dur="600" fill="hold"/>
-                                        <p:tgtEl>
-                                          <p:spTgt spid="7"/>
-                                        </p:tgtEl>
-                                      </p:cBhvr>
-                                      <p:from x="20000" y="20000"/>
-                                      <p:to x="100000" y="100000"/>
-                                    </p:animScale>
-                                  </p:childTnLst>
-                                </p:cTn>
-                              </p:par>
-                            </p:childTnLst>
-                          </p:cTn>
-                        </p:par>
-                      </p:childTnLst>
-                    </p:cTn>
-                  </p:par>
-                  <p:par>
-                    <p:cTn id="18" fill="hold">
-                      <p:stCondLst>
-                        <p:cond delay="indefinite"/>
-                      </p:stCondLst>
-                      <p:childTnLst>
-                        <p:par>
-                          <p:cTn id="19" fill="hold">
-                            <p:stCondLst>
-                              <p:cond delay="0"/>
-                            </p:stCondLst>
-                            <p:childTnLst>
-                              <p:par>
-                                <p:cTn id="20" presetID="10" presetClass="entr" presetSubtype="0" fill="hold" grpId="0" nodeType="clickEffect">
-                                  <p:stCondLst>
-                                    <p:cond delay="0"/>
-                                  </p:stCondLst>
-                                  <p:childTnLst>
-                                    <p:set>
-                                      <p:cBhvr>
-                                        <p:cTn id="21" dur="1" fill="hold">
-                                          <p:stCondLst>
-                                            <p:cond delay="0"/>
-                                          </p:stCondLst>
-                                        </p:cTn>
-                                        <p:tgtEl>
-                                          <p:spTgt spid="8">
-                                            <p:txEl>
-                                              <p:pRg st="0" end="0"/>
-                                            </p:txEl>
-                                          </p:spTgt>
-                                        </p:tgtEl>
-                                        <p:attrNameLst>
-                                          <p:attrName>style.visibility</p:attrName>
-                                        </p:attrNameLst>
-                                      </p:cBhvr>
-                                      <p:to>
-                                        <p:strVal val="visible"/>
-                                      </p:to>
-                                    </p:set>
-                                    <p:animEffect transition="in" filter="fade">
-                                      <p:cBhvr>
-                                        <p:cTn id="22" dur="400"/>
-                                        <p:tgtEl>
-                                          <p:spTgt spid="8">
-                                            <p:txEl>
-                                              <p:pRg st="0" end="0"/>
-                                            </p:txEl>
-                                          </p:spTgt>
                                         </p:tgtEl>
                                       </p:cBhvr>
                                     </p:animEffect>
@@ -6439,26 +6421,26 @@
                     </p:cTn>
                   </p:par>
                   <p:par>
-                    <p:cTn id="23" fill="hold">
+                    <p:cTn id="17" fill="hold">
                       <p:stCondLst>
                         <p:cond delay="indefinite"/>
                       </p:stCondLst>
                       <p:childTnLst>
                         <p:par>
-                          <p:cTn id="24" fill="hold">
+                          <p:cTn id="18" fill="hold">
                             <p:stCondLst>
                               <p:cond delay="0"/>
                             </p:stCondLst>
                             <p:childTnLst>
                               <p:par>
-                                <p:cTn id="25" presetID="10" presetClass="entr" presetSubtype="0" fill="hold" grpId="0" nodeType="clickEffect">
+                                <p:cTn id="19" presetID="10" presetClass="entr" presetSubtype="0" fill="hold" grpId="0" nodeType="clickEffect">
                                   <p:stCondLst>
                                     <p:cond delay="0"/>
                                   </p:stCondLst>
                                   <p:childTnLst>
                                     <p:set>
                                       <p:cBhvr>
-                                        <p:cTn id="26" dur="1" fill="hold">
+                                        <p:cTn id="20" dur="1" fill="hold">
                                           <p:stCondLst>
                                             <p:cond delay="0"/>
                                           </p:stCondLst>
@@ -6466,7 +6448,7 @@
                                         <p:tgtEl>
                                           <p:spTgt spid="8">
                                             <p:txEl>
-                                              <p:pRg st="1" end="1"/>
+                                              <p:pRg st="0" end="0"/>
                                             </p:txEl>
                                           </p:spTgt>
                                         </p:tgtEl>
@@ -6480,11 +6462,11 @@
                                     </p:set>
                                     <p:animEffect transition="in" filter="fade">
                                       <p:cBhvr>
-                                        <p:cTn id="27" dur="400"/>
+                                        <p:cTn id="21" dur="400"/>
                                         <p:tgtEl>
                                           <p:spTgt spid="8">
                                             <p:txEl>
-                                              <p:pRg st="1" end="1"/>
+                                              <p:pRg st="0" end="0"/>
                                             </p:txEl>
                                           </p:spTgt>
                                         </p:tgtEl>
@@ -6500,26 +6482,26 @@
                     </p:cTn>
                   </p:par>
                   <p:par>
-                    <p:cTn id="28" fill="hold">
+                    <p:cTn id="22" fill="hold">
                       <p:stCondLst>
                         <p:cond delay="indefinite"/>
                       </p:stCondLst>
                       <p:childTnLst>
                         <p:par>
-                          <p:cTn id="29" fill="hold">
+                          <p:cTn id="23" fill="hold">
                             <p:stCondLst>
                               <p:cond delay="0"/>
                             </p:stCondLst>
                             <p:childTnLst>
                               <p:par>
-                                <p:cTn id="30" presetID="10" presetClass="entr" presetSubtype="0" fill="hold" grpId="0" nodeType="clickEffect">
+                                <p:cTn id="24" presetID="10" presetClass="entr" presetSubtype="0" fill="hold" grpId="0" nodeType="clickEffect">
                                   <p:stCondLst>
                                     <p:cond delay="0"/>
                                   </p:stCondLst>
                                   <p:childTnLst>
                                     <p:set>
                                       <p:cBhvr>
-                                        <p:cTn id="31" dur="1" fill="hold">
+                                        <p:cTn id="25" dur="1" fill="hold">
                                           <p:stCondLst>
                                             <p:cond delay="0"/>
                                           </p:stCondLst>
@@ -6527,7 +6509,7 @@
                                         <p:tgtEl>
                                           <p:spTgt spid="8">
                                             <p:txEl>
-                                              <p:pRg st="2" end="2"/>
+                                              <p:pRg st="1" end="1"/>
                                             </p:txEl>
                                           </p:spTgt>
                                         </p:tgtEl>
@@ -6541,11 +6523,11 @@
                                     </p:set>
                                     <p:animEffect transition="in" filter="fade">
                                       <p:cBhvr>
-                                        <p:cTn id="32" dur="400"/>
+                                        <p:cTn id="26" dur="400"/>
                                         <p:tgtEl>
                                           <p:spTgt spid="8">
                                             <p:txEl>
-                                              <p:pRg st="2" end="2"/>
+                                              <p:pRg st="1" end="1"/>
                                             </p:txEl>
                                           </p:spTgt>
                                         </p:tgtEl>
@@ -6561,26 +6543,26 @@
                     </p:cTn>
                   </p:par>
                   <p:par>
-                    <p:cTn id="33" fill="hold">
+                    <p:cTn id="27" fill="hold">
                       <p:stCondLst>
                         <p:cond delay="indefinite"/>
                       </p:stCondLst>
                       <p:childTnLst>
                         <p:par>
-                          <p:cTn id="34" fill="hold">
+                          <p:cTn id="28" fill="hold">
                             <p:stCondLst>
                               <p:cond delay="0"/>
                             </p:stCondLst>
                             <p:childTnLst>
                               <p:par>
-                                <p:cTn id="35" presetID="10" presetClass="entr" presetSubtype="0" fill="hold" grpId="0" nodeType="clickEffect">
+                                <p:cTn id="29" presetID="10" presetClass="entr" presetSubtype="0" fill="hold" grpId="0" nodeType="clickEffect">
                                   <p:stCondLst>
                                     <p:cond delay="0"/>
                                   </p:stCondLst>
                                   <p:childTnLst>
                                     <p:set>
                                       <p:cBhvr>
-                                        <p:cTn id="36" dur="1" fill="hold">
+                                        <p:cTn id="30" dur="1" fill="hold">
                                           <p:stCondLst>
                                             <p:cond delay="0"/>
                                           </p:stCondLst>
@@ -6588,7 +6570,7 @@
                                         <p:tgtEl>
                                           <p:spTgt spid="8">
                                             <p:txEl>
-                                              <p:pRg st="3" end="3"/>
+                                              <p:pRg st="2" end="2"/>
                                             </p:txEl>
                                           </p:spTgt>
                                         </p:tgtEl>
@@ -6602,11 +6584,11 @@
                                     </p:set>
                                     <p:animEffect transition="in" filter="fade">
                                       <p:cBhvr>
-                                        <p:cTn id="37" dur="400"/>
+                                        <p:cTn id="31" dur="400"/>
                                         <p:tgtEl>
                                           <p:spTgt spid="8">
                                             <p:txEl>
-                                              <p:pRg st="3" end="3"/>
+                                              <p:pRg st="2" end="2"/>
                                             </p:txEl>
                                           </p:spTgt>
                                         </p:tgtEl>
@@ -6622,26 +6604,26 @@
                     </p:cTn>
                   </p:par>
                   <p:par>
-                    <p:cTn id="38" fill="hold">
+                    <p:cTn id="32" fill="hold">
                       <p:stCondLst>
                         <p:cond delay="indefinite"/>
                       </p:stCondLst>
                       <p:childTnLst>
                         <p:par>
-                          <p:cTn id="39" fill="hold">
+                          <p:cTn id="33" fill="hold">
                             <p:stCondLst>
                               <p:cond delay="0"/>
                             </p:stCondLst>
                             <p:childTnLst>
                               <p:par>
-                                <p:cTn id="40" presetID="10" presetClass="entr" presetSubtype="0" fill="hold" grpId="0" nodeType="clickEffect">
+                                <p:cTn id="34" presetID="10" presetClass="entr" presetSubtype="0" fill="hold" grpId="0" nodeType="clickEffect">
                                   <p:stCondLst>
                                     <p:cond delay="0"/>
                                   </p:stCondLst>
                                   <p:childTnLst>
                                     <p:set>
                                       <p:cBhvr>
-                                        <p:cTn id="41" dur="1" fill="hold">
+                                        <p:cTn id="35" dur="1" fill="hold">
                                           <p:stCondLst>
                                             <p:cond delay="0"/>
                                           </p:stCondLst>
@@ -6649,7 +6631,7 @@
                                         <p:tgtEl>
                                           <p:spTgt spid="8">
                                             <p:txEl>
-                                              <p:pRg st="4" end="4"/>
+                                              <p:pRg st="3" end="3"/>
                                             </p:txEl>
                                           </p:spTgt>
                                         </p:tgtEl>
@@ -6663,11 +6645,11 @@
                                     </p:set>
                                     <p:animEffect transition="in" filter="fade">
                                       <p:cBhvr>
-                                        <p:cTn id="42" dur="400"/>
+                                        <p:cTn id="36" dur="400"/>
                                         <p:tgtEl>
                                           <p:spTgt spid="8">
                                             <p:txEl>
-                                              <p:pRg st="4" end="4"/>
+                                              <p:pRg st="3" end="3"/>
                                             </p:txEl>
                                           </p:spTgt>
                                         </p:tgtEl>
@@ -6683,26 +6665,87 @@
                     </p:cTn>
                   </p:par>
                   <p:par>
-                    <p:cTn id="43" fill="hold">
+                    <p:cTn id="37" fill="hold">
                       <p:stCondLst>
                         <p:cond delay="indefinite"/>
                       </p:stCondLst>
                       <p:childTnLst>
                         <p:par>
-                          <p:cTn id="44" fill="hold">
+                          <p:cTn id="38" fill="hold">
                             <p:stCondLst>
                               <p:cond delay="0"/>
                             </p:stCondLst>
                             <p:childTnLst>
                               <p:par>
-                                <p:cTn id="45" presetID="10" presetClass="entr" presetSubtype="0" fill="hold" grpId="0" nodeType="clickEffect">
+                                <p:cTn id="39" presetID="10" presetClass="entr" presetSubtype="0" fill="hold" grpId="0" nodeType="clickEffect">
                                   <p:stCondLst>
                                     <p:cond delay="0"/>
                                   </p:stCondLst>
                                   <p:childTnLst>
                                     <p:set>
                                       <p:cBhvr>
-                                        <p:cTn id="46" dur="1" fill="hold">
+                                        <p:cTn id="40" dur="1" fill="hold">
+                                          <p:stCondLst>
+                                            <p:cond delay="0"/>
+                                          </p:stCondLst>
+                                        </p:cTn>
+                                        <p:tgtEl>
+                                          <p:spTgt spid="8">
+                                            <p:txEl>
+                                              <p:pRg st="4" end="4"/>
+                                            </p:txEl>
+                                          </p:spTgt>
+                                        </p:tgtEl>
+                                        <p:attrNameLst>
+                                          <p:attrName>style.visibility</p:attrName>
+                                        </p:attrNameLst>
+                                      </p:cBhvr>
+                                      <p:to>
+                                        <p:strVal val="visible"/>
+                                      </p:to>
+                                    </p:set>
+                                    <p:animEffect transition="in" filter="fade">
+                                      <p:cBhvr>
+                                        <p:cTn id="41" dur="400"/>
+                                        <p:tgtEl>
+                                          <p:spTgt spid="8">
+                                            <p:txEl>
+                                              <p:pRg st="4" end="4"/>
+                                            </p:txEl>
+                                          </p:spTgt>
+                                        </p:tgtEl>
+                                      </p:cBhvr>
+                                    </p:animEffect>
+                                  </p:childTnLst>
+                                </p:cTn>
+                              </p:par>
+                            </p:childTnLst>
+                          </p:cTn>
+                        </p:par>
+                      </p:childTnLst>
+                    </p:cTn>
+                  </p:par>
+                  <p:par>
+                    <p:cTn id="42" fill="hold">
+                      <p:stCondLst>
+                        <p:cond delay="indefinite"/>
+                      </p:stCondLst>
+                      <p:childTnLst>
+                        <p:par>
+                          <p:cTn id="43" fill="hold">
+                            <p:stCondLst>
+                              <p:cond delay="0"/>
+                            </p:stCondLst>
+                            <p:childTnLst>
+                              <p:par>
+                                <p:cTn id="44" presetID="10" presetClass="entr" presetSubtype="0" fill="hold" grpId="0" nodeType="clickEffect">
+                                  <p:stCondLst>
+                                    <p:cond delay="0"/>
+                                  </p:stCondLst>
+                                  <p:childTnLst>
+                                    <p:set>
+                                      <p:cBhvr>
+                                        <p:cTn id="45" dur="1" fill="hold">
                                           <p:stCondLst>
                                             <p:cond delay="0"/>
                                           </p:stCondLst>
@@ -6724,7 +6767,7 @@
                                     </p:set>
                                     <p:animEffect transition="in" filter="fade">
                                       <p:cBhvr>
-                                        <p:cTn id="47" dur="400"/>
+                                        <p:cTn id="46" dur="400"/>
                                         <p:tgtEl>
                                           <p:spTgt spid="8">
                                             <p:txEl>
@@ -6958,7 +7001,7 @@
         <p:spPr>
           <a:xfrm>
             <a:off x="731520" y="1371600"/>
-            <a:ext cx="10637215" cy="5120640"/>
+            <a:ext cx="7345375" cy="5120640"/>
           </a:xfrm>
           <a:prstGeom prst="rect">
             <a:avLst/>
@@ -6973,11 +7016,11 @@
           <a:p>
             <a:pPr>
               <a:spcAft>
-                <a:spcPts val="1500"/>
+                <a:spcPts val="1400"/>
               </a:spcAft>
             </a:pPr>
             <a:r>
-              <a:rPr sz="1800" b="1" i="0">
+              <a:rPr sz="1700" b="1" i="0">
                 <a:solidFill>
                   <a:srgbClr val="80340D"/>
                 </a:solidFill>
@@ -6986,7 +7029,7 @@
               <a:t>➢  </a:t>
             </a:r>
             <a:r>
-              <a:rPr sz="1800" b="1" i="0">
+              <a:rPr sz="1700" b="1" i="0">
                 <a:solidFill>
                   <a:srgbClr val="261A10"/>
                 </a:solidFill>
@@ -6995,7 +7038,7 @@
               <a:t>Dynasties rarely survive their strongmen: </a:t>
             </a:r>
             <a:r>
-              <a:rPr sz="1800" b="0" i="0">
+              <a:rPr sz="1700" b="0" i="0">
                 <a:solidFill>
                   <a:srgbClr val="261A10"/>
                 </a:solidFill>
@@ -7007,11 +7050,11 @@
           <a:p>
             <a:pPr>
               <a:spcAft>
-                <a:spcPts val="1500"/>
+                <a:spcPts val="1400"/>
               </a:spcAft>
             </a:pPr>
             <a:r>
-              <a:rPr sz="1800" b="1" i="0">
+              <a:rPr sz="1700" b="1" i="0">
                 <a:solidFill>
                   <a:srgbClr val="80340D"/>
                 </a:solidFill>
@@ -7020,7 +7063,7 @@
               <a:t>➢  </a:t>
             </a:r>
             <a:r>
-              <a:rPr sz="1800" b="1" i="0">
+              <a:rPr sz="1700" b="1" i="0">
                 <a:solidFill>
                   <a:srgbClr val="261A10"/>
                 </a:solidFill>
@@ -7029,7 +7072,7 @@
               <a:t>Three wasted years: </a:t>
             </a:r>
             <a:r>
-              <a:rPr sz="1800" b="0" i="0">
+              <a:rPr sz="1700" b="0" i="0">
                 <a:solidFill>
                   <a:srgbClr val="261A10"/>
                 </a:solidFill>
@@ -7041,11 +7084,11 @@
           <a:p>
             <a:pPr>
               <a:spcAft>
-                <a:spcPts val="1500"/>
+                <a:spcPts val="1400"/>
               </a:spcAft>
             </a:pPr>
             <a:r>
-              <a:rPr sz="1800" b="1" i="0">
+              <a:rPr sz="1700" b="1" i="0">
                 <a:solidFill>
                   <a:srgbClr val="80340D"/>
                 </a:solidFill>
@@ -7054,7 +7097,7 @@
               <a:t>➢  </a:t>
             </a:r>
             <a:r>
-              <a:rPr sz="1800" b="1" i="0">
+              <a:rPr sz="1700" b="1" i="0">
                 <a:solidFill>
                   <a:srgbClr val="261A10"/>
                 </a:solidFill>
@@ -7063,7 +7106,7 @@
               <a:t>Rise of the Khaljis: </a:t>
             </a:r>
             <a:r>
-              <a:rPr sz="1800" b="0" i="0">
+              <a:rPr sz="1700" b="0" i="0">
                 <a:solidFill>
                   <a:srgbClr val="261A10"/>
                 </a:solidFill>
@@ -7075,11 +7118,11 @@
           <a:p>
             <a:pPr>
               <a:spcAft>
-                <a:spcPts val="1500"/>
+                <a:spcPts val="1400"/>
               </a:spcAft>
             </a:pPr>
             <a:r>
-              <a:rPr sz="1800" b="1" i="0">
+              <a:rPr sz="1700" b="1" i="0">
                 <a:solidFill>
                   <a:srgbClr val="80340D"/>
                 </a:solidFill>
@@ -7088,7 +7131,7 @@
               <a:t>➢  </a:t>
             </a:r>
             <a:r>
-              <a:rPr sz="1800" b="1" i="0">
+              <a:rPr sz="1700" b="1" i="0">
                 <a:solidFill>
                   <a:srgbClr val="261A10"/>
                 </a:solidFill>
@@ -7097,7 +7140,7 @@
               <a:t>1290 – Khalji Revolution: </a:t>
             </a:r>
             <a:r>
-              <a:rPr sz="1800" b="0" i="0">
+              <a:rPr sz="1700" b="0" i="0">
                 <a:solidFill>
                   <a:srgbClr val="261A10"/>
                 </a:solidFill>
@@ -7109,11 +7152,11 @@
           <a:p>
             <a:pPr>
               <a:spcAft>
-                <a:spcPts val="1500"/>
+                <a:spcPts val="1400"/>
               </a:spcAft>
             </a:pPr>
             <a:r>
-              <a:rPr sz="1800" b="1" i="0">
+              <a:rPr sz="1700" b="1" i="0">
                 <a:solidFill>
                   <a:srgbClr val="80340D"/>
                 </a:solidFill>
@@ -7122,7 +7165,7 @@
               <a:t>➢  </a:t>
             </a:r>
             <a:r>
-              <a:rPr sz="1800" b="1" i="0">
+              <a:rPr sz="1700" b="1" i="0">
                 <a:solidFill>
                   <a:srgbClr val="261A10"/>
                 </a:solidFill>
@@ -7131,13 +7174,142 @@
               <a:t>More than a family change: </a:t>
             </a:r>
             <a:r>
-              <a:rPr sz="1800" b="0" i="0">
+              <a:rPr sz="1700" b="0" i="0">
                 <a:solidFill>
                   <a:srgbClr val="261A10"/>
                 </a:solidFill>
                 <a:latin typeface="Times New Roman"/>
               </a:rPr>
               <a:t>the Turkish slave elite's monopoly broke forever — the dynasty fell to the very principle that had raised it: power belongs to the capable.</a:t>
+            </a:r>
+          </a:p>
+        </p:txBody>
+      </p:sp>
+      <p:pic>
+        <p:nvPicPr>
+          <p:cNvPr id="7" name="Picture 6" descr="sword_r.png"/>
+          <p:cNvPicPr>
+            <a:picLocks noChangeAspect="1"/>
+          </p:cNvPicPr>
+          <p:nvPr/>
+        </p:nvPicPr>
+        <p:blipFill>
+          <a:blip r:embed="rId2"/>
+          <a:stretch>
+            <a:fillRect/>
+          </a:stretch>
+        </p:blipFill>
+        <p:spPr>
+          <a:xfrm>
+            <a:off x="8732520" y="2377440"/>
+            <a:ext cx="2651760" cy="1840154"/>
+          </a:xfrm>
+          <a:prstGeom prst="rect">
+            <a:avLst/>
+          </a:prstGeom>
+        </p:spPr>
+      </p:pic>
+      <p:pic>
+        <p:nvPicPr>
+          <p:cNvPr id="8" name="Picture 7" descr="sword_l.png"/>
+          <p:cNvPicPr>
+            <a:picLocks noChangeAspect="1"/>
+          </p:cNvPicPr>
+          <p:nvPr/>
+        </p:nvPicPr>
+        <p:blipFill>
+          <a:blip r:embed="rId3"/>
+          <a:stretch>
+            <a:fillRect/>
+          </a:stretch>
+        </p:blipFill>
+        <p:spPr>
+          <a:xfrm>
+            <a:off x="8732520" y="2377440"/>
+            <a:ext cx="2651760" cy="1840154"/>
+          </a:xfrm>
+          <a:prstGeom prst="rect">
+            <a:avLst/>
+          </a:prstGeom>
+        </p:spPr>
+      </p:pic>
+      <p:sp>
+        <p:nvSpPr>
+          <p:cNvPr id="9" name="8-Point Star 8"/>
+          <p:cNvSpPr/>
+          <p:nvPr/>
+        </p:nvSpPr>
+        <p:spPr>
+          <a:xfrm>
+            <a:off x="9646920" y="2834640"/>
+            <a:ext cx="822960" cy="822960"/>
+          </a:xfrm>
+          <a:prstGeom prst="star8">
+            <a:avLst/>
+          </a:prstGeom>
+          <a:solidFill>
+            <a:srgbClr val="C88A3C"/>
+          </a:solidFill>
+          <a:ln w="15875">
+            <a:solidFill>
+              <a:srgbClr val="80340D"/>
+            </a:solidFill>
+          </a:ln>
+          <a:effectLst/>
+        </p:spPr>
+        <p:style>
+          <a:lnRef idx="1">
+            <a:schemeClr val="accent1"/>
+          </a:lnRef>
+          <a:fillRef idx="3">
+            <a:schemeClr val="accent1"/>
+          </a:fillRef>
+          <a:effectRef idx="2">
+            <a:schemeClr val="accent1"/>
+          </a:effectRef>
+          <a:fontRef idx="minor">
+            <a:schemeClr val="lt1"/>
+          </a:fontRef>
+        </p:style>
+        <p:txBody>
+          <a:bodyPr rtlCol="0" anchor="ctr"/>
+          <a:lstStyle/>
+          <a:p>
+            <a:pPr algn="ctr"/>
+          </a:p>
+        </p:txBody>
+      </p:sp>
+      <p:sp>
+        <p:nvSpPr>
+          <p:cNvPr id="10" name="TextBox 9"/>
+          <p:cNvSpPr txBox="1"/>
+          <p:nvPr/>
+        </p:nvSpPr>
+        <p:spPr>
+          <a:xfrm>
+            <a:off x="8549640" y="4572000"/>
+            <a:ext cx="3200400" cy="548640"/>
+          </a:xfrm>
+          <a:prstGeom prst="rect">
+            <a:avLst/>
+          </a:prstGeom>
+          <a:noFill/>
+        </p:spPr>
+        <p:txBody>
+          <a:bodyPr wrap="square">
+            <a:spAutoFit/>
+          </a:bodyPr>
+          <a:lstStyle/>
+          <a:p>
+            <a:pPr algn="ctr"/>
+            <a:r>
+              <a:rPr sz="1200" b="0" i="1">
+                <a:solidFill>
+                  <a:srgbClr val="7F7F7F"/>
+                </a:solidFill>
+                <a:latin typeface="Times New Roman"/>
+              </a:rPr>
+              <a:t>1290 — the Khalji swords fall</a:t>
             </a:r>
           </a:p>
         </p:txBody>
@@ -7516,6 +7688,240 @@
                       </p:childTnLst>
                     </p:cTn>
                   </p:par>
+                  <p:par>
+                    <p:cTn id="33" fill="hold">
+                      <p:stCondLst>
+                        <p:cond delay="indefinite"/>
+                      </p:stCondLst>
+                      <p:childTnLst>
+                        <p:par>
+                          <p:cTn id="34" fill="hold">
+                            <p:stCondLst>
+                              <p:cond delay="0"/>
+                            </p:stCondLst>
+                            <p:childTnLst>
+                              <p:par>
+                                <p:cTn id="35" presetID="2" presetClass="entr" presetSubtype="0" fill="hold" grpId="0" nodeType="clickEffect">
+                                  <p:stCondLst>
+                                    <p:cond delay="0"/>
+                                  </p:stCondLst>
+                                  <p:childTnLst>
+                                    <p:set>
+                                      <p:cBhvr>
+                                        <p:cTn id="36" dur="1" fill="hold">
+                                          <p:stCondLst>
+                                            <p:cond delay="0"/>
+                                          </p:stCondLst>
+                                        </p:cTn>
+                                        <p:tgtEl>
+                                          <p:spTgt spid="7"/>
+                                        </p:tgtEl>
+                                        <p:attrNameLst>
+                                          <p:attrName>style.visibility</p:attrName>
+                                        </p:attrNameLst>
+                                      </p:cBhvr>
+                                      <p:to>
+                                        <p:strVal val="visible"/>
+                                      </p:to>
+                                    </p:set>
+                                    <p:animMotion origin="layout" path="M -0.5 0.35 L 0 0 E" pathEditMode="relative" ptsTypes="">
+                                      <p:cBhvr>
+                                        <p:cTn id="37" dur="650" fill="hold"/>
+                                        <p:tgtEl>
+                                          <p:spTgt spid="7"/>
+                                        </p:tgtEl>
+                                        <p:attrNameLst>
+                                          <p:attrName>ppt_x</p:attrName>
+                                          <p:attrName>ppt_y</p:attrName>
+                                        </p:attrNameLst>
+                                      </p:cBhvr>
+                                    </p:animMotion>
+                                    <p:animRot by="1500000">
+                                      <p:cBhvr>
+                                        <p:cTn id="38" dur="650" fill="hold"/>
+                                        <p:tgtEl>
+                                          <p:spTgt spid="7"/>
+                                        </p:tgtEl>
+                                        <p:attrNameLst>
+                                          <p:attrName>r</p:attrName>
+                                        </p:attrNameLst>
+                                      </p:cBhvr>
+                                    </p:animRot>
+                                  </p:childTnLst>
+                                </p:cTn>
+                              </p:par>
+                              <p:par>
+                                <p:cTn id="39" presetID="2" presetClass="entr" presetSubtype="0" fill="hold" grpId="0" nodeType="withEffect">
+                                  <p:stCondLst>
+                                    <p:cond delay="0"/>
+                                  </p:stCondLst>
+                                  <p:childTnLst>
+                                    <p:set>
+                                      <p:cBhvr>
+                                        <p:cTn id="40" dur="1" fill="hold">
+                                          <p:stCondLst>
+                                            <p:cond delay="0"/>
+                                          </p:stCondLst>
+                                        </p:cTn>
+                                        <p:tgtEl>
+                                          <p:spTgt spid="8"/>
+                                        </p:tgtEl>
+                                        <p:attrNameLst>
+                                          <p:attrName>style.visibility</p:attrName>
+                                        </p:attrNameLst>
+                                      </p:cBhvr>
+                                      <p:to>
+                                        <p:strVal val="visible"/>
+                                      </p:to>
+                                    </p:set>
+                                    <p:animMotion origin="layout" path="M 0.35 0.35 L 0 0 E" pathEditMode="relative" ptsTypes="">
+                                      <p:cBhvr>
+                                        <p:cTn id="41" dur="650" fill="hold"/>
+                                        <p:tgtEl>
+                                          <p:spTgt spid="8"/>
+                                        </p:tgtEl>
+                                        <p:attrNameLst>
+                                          <p:attrName>ppt_x</p:attrName>
+                                          <p:attrName>ppt_y</p:attrName>
+                                        </p:attrNameLst>
+                                      </p:cBhvr>
+                                    </p:animMotion>
+                                    <p:animRot by="-1500000">
+                                      <p:cBhvr>
+                                        <p:cTn id="42" dur="650" fill="hold"/>
+                                        <p:tgtEl>
+                                          <p:spTgt spid="8"/>
+                                        </p:tgtEl>
+                                        <p:attrNameLst>
+                                          <p:attrName>r</p:attrName>
+                                        </p:attrNameLst>
+                                      </p:cBhvr>
+                                    </p:animRot>
+                                  </p:childTnLst>
+                                </p:cTn>
+                              </p:par>
+                              <p:par>
+                                <p:cTn id="43" presetID="53" presetClass="entr" presetSubtype="0" fill="hold" grpId="0" nodeType="withEffect">
+                                  <p:stCondLst>
+                                    <p:cond delay="600"/>
+                                  </p:stCondLst>
+                                  <p:childTnLst>
+                                    <p:set>
+                                      <p:cBhvr>
+                                        <p:cTn id="44" dur="1" fill="hold">
+                                          <p:stCondLst>
+                                            <p:cond delay="0"/>
+                                          </p:stCondLst>
+                                        </p:cTn>
+                                        <p:tgtEl>
+                                          <p:spTgt spid="9"/>
+                                        </p:tgtEl>
+                                        <p:attrNameLst>
+                                          <p:attrName>style.visibility</p:attrName>
+                                        </p:attrNameLst>
+                                      </p:cBhvr>
+                                      <p:to>
+                                        <p:strVal val="visible"/>
+                                      </p:to>
+                                    </p:set>
+                                    <p:animEffect transition="in" filter="fade">
+                                      <p:cBhvr>
+                                        <p:cTn id="45" dur="300"/>
+                                        <p:tgtEl>
+                                          <p:spTgt spid="9"/>
+                                        </p:tgtEl>
+                                      </p:cBhvr>
+                                    </p:animEffect>
+                                    <p:animScale>
+                                      <p:cBhvr>
+                                        <p:cTn id="46" dur="300" fill="hold"/>
+                                        <p:tgtEl>
+                                          <p:spTgt spid="9"/>
+                                        </p:tgtEl>
+                                      </p:cBhvr>
+                                      <p:from x="20000" y="20000"/>
+                                      <p:to x="100000" y="100000"/>
+                                    </p:animScale>
+                                  </p:childTnLst>
+                                </p:cTn>
+                              </p:par>
+                              <p:par>
+                                <p:cTn id="47" presetID="10" presetClass="entr" presetSubtype="0" fill="hold" grpId="0" nodeType="withEffect">
+                                  <p:stCondLst>
+                                    <p:cond delay="850"/>
+                                  </p:stCondLst>
+                                  <p:childTnLst>
+                                    <p:set>
+                                      <p:cBhvr>
+                                        <p:cTn id="48" dur="1" fill="hold">
+                                          <p:stCondLst>
+                                            <p:cond delay="0"/>
+                                          </p:stCondLst>
+                                        </p:cTn>
+                                        <p:tgtEl>
+                                          <p:spTgt spid="10"/>
+                                        </p:tgtEl>
+                                        <p:attrNameLst>
+                                          <p:attrName>style.visibility</p:attrName>
+                                        </p:attrNameLst>
+                                      </p:cBhvr>
+                                      <p:to>
+                                        <p:strVal val="visible"/>
+                                      </p:to>
+                                    </p:set>
+                                    <p:animEffect transition="in" filter="fade">
+                                      <p:cBhvr>
+                                        <p:cTn id="49" dur="400"/>
+                                        <p:tgtEl>
+                                          <p:spTgt spid="10"/>
+                                        </p:tgtEl>
+                                      </p:cBhvr>
+                                    </p:animEffect>
+                                  </p:childTnLst>
+                                </p:cTn>
+                              </p:par>
+                            </p:childTnLst>
+                          </p:cTn>
+                        </p:par>
+                      </p:childTnLst>
+                    </p:cTn>
+                  </p:par>
+                  <p:par>
+                    <p:cTn id="50" fill="hold">
+                      <p:stCondLst>
+                        <p:cond delay="0"/>
+                      </p:stCondLst>
+                      <p:childTnLst>
+                        <p:par>
+                          <p:cTn id="51" fill="hold">
+                            <p:stCondLst>
+                              <p:cond delay="0"/>
+                            </p:stCondLst>
+                            <p:childTnLst>
+                              <p:par>
+                                <p:cTn id="52" presetID="26" presetClass="emph" presetSubtype="0" fill="hold" grpId="0" nodeType="afterEffect">
+                                  <p:stCondLst>
+                                    <p:cond delay="0"/>
+                                  </p:stCondLst>
+                                  <p:childTnLst>
+                                    <p:animScale>
+                                      <p:cBhvr>
+                                        <p:cTn id="53" dur="650" autoRev="1" repeatCount="4000" fill="hold"/>
+                                        <p:tgtEl>
+                                          <p:spTgt spid="9"/>
+                                        </p:tgtEl>
+                                      </p:cBhvr>
+                                      <p:by x="110000" y="110000"/>
+                                    </p:animScale>
+                                  </p:childTnLst>
+                                </p:cTn>
+                              </p:par>
+                            </p:childTnLst>
+                          </p:cTn>
+                        </p:par>
+                      </p:childTnLst>
+                    </p:cTn>
+                  </p:par>
                 </p:childTnLst>
               </p:cTn>
               <p:prevCondLst>
@@ -7540,6 +7946,10 @@
     <p:bldLst>
       <p:bldP spid="5" grpId="0"/>
       <p:bldP spid="6" grpId="0" build="p"/>
+      <p:bldP spid="7" grpId="0"/>
+      <p:bldP spid="8" grpId="0"/>
+      <p:bldP spid="9" grpId="0"/>
+      <p:bldP spid="10" grpId="0"/>
     </p:bldLst>
   </p:timing>
 </p:sld>
@@ -8139,7 +8549,7 @@
                                 </p:cTn>
                               </p:par>
                               <p:par>
-                                <p:cTn id="14" presetID="53" presetClass="entr" presetSubtype="0" fill="hold" grpId="0" nodeType="withEffect">
+                                <p:cTn id="14" presetID="10" presetClass="entr" presetSubtype="0" fill="hold" grpId="0" nodeType="withEffect">
                                   <p:stCondLst>
                                     <p:cond delay="150"/>
                                   </p:stCondLst>
@@ -8167,77 +8577,6 @@
                                         <p:cTn id="16" dur="600"/>
                                         <p:tgtEl>
                                           <p:spTgt spid="7"/>
-                                        </p:tgtEl>
-                                      </p:cBhvr>
-                                    </p:animEffect>
-                                    <p:animScale>
-                                      <p:cBhvr>
-                                        <p:cTn id="17" dur="600" fill="hold"/>
-                                        <p:tgtEl>
-                                          <p:spTgt spid="7"/>
-                                        </p:tgtEl>
-                                      </p:cBhvr>
-                                      <p:from x="20000" y="20000"/>
-                                      <p:to x="100000" y="100000"/>
-                                    </p:animScale>
-                                  </p:childTnLst>
-                                </p:cTn>
-                              </p:par>
-                            </p:childTnLst>
-                          </p:cTn>
-                        </p:par>
-                      </p:childTnLst>
-                    </p:cTn>
-                  </p:par>
-                  <p:par>
-                    <p:cTn id="18" fill="hold">
-                      <p:stCondLst>
-                        <p:cond delay="indefinite"/>
-                      </p:stCondLst>
-                      <p:childTnLst>
-                        <p:par>
-                          <p:cTn id="19" fill="hold">
-                            <p:stCondLst>
-                              <p:cond delay="0"/>
-                            </p:stCondLst>
-                            <p:childTnLst>
-                              <p:par>
-                                <p:cTn id="20" presetID="10" presetClass="entr" presetSubtype="0" fill="hold" grpId="0" nodeType="clickEffect">
-                                  <p:stCondLst>
-                                    <p:cond delay="0"/>
-                                  </p:stCondLst>
-                                  <p:childTnLst>
-                                    <p:set>
-                                      <p:cBhvr>
-                                        <p:cTn id="21" dur="1" fill="hold">
-                                          <p:stCondLst>
-                                            <p:cond delay="0"/>
-                                          </p:stCondLst>
-                                        </p:cTn>
-                                        <p:tgtEl>
-                                          <p:spTgt spid="8">
-                                            <p:txEl>
-                                              <p:pRg st="0" end="0"/>
-                                            </p:txEl>
-                                          </p:spTgt>
-                                        </p:tgtEl>
-                                        <p:attrNameLst>
-                                          <p:attrName>style.visibility</p:attrName>
-                                        </p:attrNameLst>
-                                      </p:cBhvr>
-                                      <p:to>
-                                        <p:strVal val="visible"/>
-                                      </p:to>
-                                    </p:set>
-                                    <p:animEffect transition="in" filter="fade">
-                                      <p:cBhvr>
-                                        <p:cTn id="22" dur="400"/>
-                                        <p:tgtEl>
-                                          <p:spTgt spid="8">
-                                            <p:txEl>
-                                              <p:pRg st="0" end="0"/>
-                                            </p:txEl>
-                                          </p:spTgt>
                                         </p:tgtEl>
                                       </p:cBhvr>
                                     </p:animEffect>
@@ -8251,26 +8590,26 @@
                     </p:cTn>
                   </p:par>
                   <p:par>
-                    <p:cTn id="23" fill="hold">
+                    <p:cTn id="17" fill="hold">
                       <p:stCondLst>
                         <p:cond delay="indefinite"/>
                       </p:stCondLst>
                       <p:childTnLst>
                         <p:par>
-                          <p:cTn id="24" fill="hold">
+                          <p:cTn id="18" fill="hold">
                             <p:stCondLst>
                               <p:cond delay="0"/>
                             </p:stCondLst>
                             <p:childTnLst>
                               <p:par>
-                                <p:cTn id="25" presetID="10" presetClass="entr" presetSubtype="0" fill="hold" grpId="0" nodeType="clickEffect">
+                                <p:cTn id="19" presetID="10" presetClass="entr" presetSubtype="0" fill="hold" grpId="0" nodeType="clickEffect">
                                   <p:stCondLst>
                                     <p:cond delay="0"/>
                                   </p:stCondLst>
                                   <p:childTnLst>
                                     <p:set>
                                       <p:cBhvr>
-                                        <p:cTn id="26" dur="1" fill="hold">
+                                        <p:cTn id="20" dur="1" fill="hold">
                                           <p:stCondLst>
                                             <p:cond delay="0"/>
                                           </p:stCondLst>
@@ -8278,7 +8617,7 @@
                                         <p:tgtEl>
                                           <p:spTgt spid="8">
                                             <p:txEl>
-                                              <p:pRg st="1" end="1"/>
+                                              <p:pRg st="0" end="0"/>
                                             </p:txEl>
                                           </p:spTgt>
                                         </p:tgtEl>
@@ -8292,11 +8631,11 @@
                                     </p:set>
                                     <p:animEffect transition="in" filter="fade">
                                       <p:cBhvr>
-                                        <p:cTn id="27" dur="400"/>
+                                        <p:cTn id="21" dur="400"/>
                                         <p:tgtEl>
                                           <p:spTgt spid="8">
                                             <p:txEl>
-                                              <p:pRg st="1" end="1"/>
+                                              <p:pRg st="0" end="0"/>
                                             </p:txEl>
                                           </p:spTgt>
                                         </p:tgtEl>
@@ -8312,26 +8651,26 @@
                     </p:cTn>
                   </p:par>
                   <p:par>
-                    <p:cTn id="28" fill="hold">
+                    <p:cTn id="22" fill="hold">
                       <p:stCondLst>
                         <p:cond delay="indefinite"/>
                       </p:stCondLst>
                       <p:childTnLst>
                         <p:par>
-                          <p:cTn id="29" fill="hold">
+                          <p:cTn id="23" fill="hold">
                             <p:stCondLst>
                               <p:cond delay="0"/>
                             </p:stCondLst>
                             <p:childTnLst>
                               <p:par>
-                                <p:cTn id="30" presetID="10" presetClass="entr" presetSubtype="0" fill="hold" grpId="0" nodeType="clickEffect">
+                                <p:cTn id="24" presetID="10" presetClass="entr" presetSubtype="0" fill="hold" grpId="0" nodeType="clickEffect">
                                   <p:stCondLst>
                                     <p:cond delay="0"/>
                                   </p:stCondLst>
                                   <p:childTnLst>
                                     <p:set>
                                       <p:cBhvr>
-                                        <p:cTn id="31" dur="1" fill="hold">
+                                        <p:cTn id="25" dur="1" fill="hold">
                                           <p:stCondLst>
                                             <p:cond delay="0"/>
                                           </p:stCondLst>
@@ -8339,7 +8678,7 @@
                                         <p:tgtEl>
                                           <p:spTgt spid="8">
                                             <p:txEl>
-                                              <p:pRg st="2" end="2"/>
+                                              <p:pRg st="1" end="1"/>
                                             </p:txEl>
                                           </p:spTgt>
                                         </p:tgtEl>
@@ -8353,11 +8692,11 @@
                                     </p:set>
                                     <p:animEffect transition="in" filter="fade">
                                       <p:cBhvr>
-                                        <p:cTn id="32" dur="400"/>
+                                        <p:cTn id="26" dur="400"/>
                                         <p:tgtEl>
                                           <p:spTgt spid="8">
                                             <p:txEl>
-                                              <p:pRg st="2" end="2"/>
+                                              <p:pRg st="1" end="1"/>
                                             </p:txEl>
                                           </p:spTgt>
                                         </p:tgtEl>
@@ -8373,26 +8712,26 @@
                     </p:cTn>
                   </p:par>
                   <p:par>
-                    <p:cTn id="33" fill="hold">
+                    <p:cTn id="27" fill="hold">
                       <p:stCondLst>
                         <p:cond delay="indefinite"/>
                       </p:stCondLst>
                       <p:childTnLst>
                         <p:par>
-                          <p:cTn id="34" fill="hold">
+                          <p:cTn id="28" fill="hold">
                             <p:stCondLst>
                               <p:cond delay="0"/>
                             </p:stCondLst>
                             <p:childTnLst>
                               <p:par>
-                                <p:cTn id="35" presetID="10" presetClass="entr" presetSubtype="0" fill="hold" grpId="0" nodeType="clickEffect">
+                                <p:cTn id="29" presetID="10" presetClass="entr" presetSubtype="0" fill="hold" grpId="0" nodeType="clickEffect">
                                   <p:stCondLst>
                                     <p:cond delay="0"/>
                                   </p:stCondLst>
                                   <p:childTnLst>
                                     <p:set>
                                       <p:cBhvr>
-                                        <p:cTn id="36" dur="1" fill="hold">
+                                        <p:cTn id="30" dur="1" fill="hold">
                                           <p:stCondLst>
                                             <p:cond delay="0"/>
                                           </p:stCondLst>
@@ -8400,7 +8739,7 @@
                                         <p:tgtEl>
                                           <p:spTgt spid="8">
                                             <p:txEl>
-                                              <p:pRg st="3" end="3"/>
+                                              <p:pRg st="2" end="2"/>
                                             </p:txEl>
                                           </p:spTgt>
                                         </p:tgtEl>
@@ -8414,11 +8753,11 @@
                                     </p:set>
                                     <p:animEffect transition="in" filter="fade">
                                       <p:cBhvr>
-                                        <p:cTn id="37" dur="400"/>
+                                        <p:cTn id="31" dur="400"/>
                                         <p:tgtEl>
                                           <p:spTgt spid="8">
                                             <p:txEl>
-                                              <p:pRg st="3" end="3"/>
+                                              <p:pRg st="2" end="2"/>
                                             </p:txEl>
                                           </p:spTgt>
                                         </p:tgtEl>
@@ -8434,26 +8773,26 @@
                     </p:cTn>
                   </p:par>
                   <p:par>
-                    <p:cTn id="38" fill="hold">
+                    <p:cTn id="32" fill="hold">
                       <p:stCondLst>
                         <p:cond delay="indefinite"/>
                       </p:stCondLst>
                       <p:childTnLst>
                         <p:par>
-                          <p:cTn id="39" fill="hold">
+                          <p:cTn id="33" fill="hold">
                             <p:stCondLst>
                               <p:cond delay="0"/>
                             </p:stCondLst>
                             <p:childTnLst>
                               <p:par>
-                                <p:cTn id="40" presetID="10" presetClass="entr" presetSubtype="0" fill="hold" grpId="0" nodeType="clickEffect">
+                                <p:cTn id="34" presetID="10" presetClass="entr" presetSubtype="0" fill="hold" grpId="0" nodeType="clickEffect">
                                   <p:stCondLst>
                                     <p:cond delay="0"/>
                                   </p:stCondLst>
                                   <p:childTnLst>
                                     <p:set>
                                       <p:cBhvr>
-                                        <p:cTn id="41" dur="1" fill="hold">
+                                        <p:cTn id="35" dur="1" fill="hold">
                                           <p:stCondLst>
                                             <p:cond delay="0"/>
                                           </p:stCondLst>
@@ -8461,7 +8800,7 @@
                                         <p:tgtEl>
                                           <p:spTgt spid="8">
                                             <p:txEl>
-                                              <p:pRg st="4" end="4"/>
+                                              <p:pRg st="3" end="3"/>
                                             </p:txEl>
                                           </p:spTgt>
                                         </p:tgtEl>
@@ -8475,11 +8814,11 @@
                                     </p:set>
                                     <p:animEffect transition="in" filter="fade">
                                       <p:cBhvr>
-                                        <p:cTn id="42" dur="400"/>
+                                        <p:cTn id="36" dur="400"/>
                                         <p:tgtEl>
                                           <p:spTgt spid="8">
                                             <p:txEl>
-                                              <p:pRg st="4" end="4"/>
+                                              <p:pRg st="3" end="3"/>
                                             </p:txEl>
                                           </p:spTgt>
                                         </p:tgtEl>
@@ -8495,26 +8834,87 @@
                     </p:cTn>
                   </p:par>
                   <p:par>
-                    <p:cTn id="43" fill="hold">
+                    <p:cTn id="37" fill="hold">
                       <p:stCondLst>
                         <p:cond delay="indefinite"/>
                       </p:stCondLst>
                       <p:childTnLst>
                         <p:par>
-                          <p:cTn id="44" fill="hold">
+                          <p:cTn id="38" fill="hold">
                             <p:stCondLst>
                               <p:cond delay="0"/>
                             </p:stCondLst>
                             <p:childTnLst>
                               <p:par>
-                                <p:cTn id="45" presetID="10" presetClass="entr" presetSubtype="0" fill="hold" grpId="0" nodeType="clickEffect">
+                                <p:cTn id="39" presetID="10" presetClass="entr" presetSubtype="0" fill="hold" grpId="0" nodeType="clickEffect">
                                   <p:stCondLst>
                                     <p:cond delay="0"/>
                                   </p:stCondLst>
                                   <p:childTnLst>
                                     <p:set>
                                       <p:cBhvr>
-                                        <p:cTn id="46" dur="1" fill="hold">
+                                        <p:cTn id="40" dur="1" fill="hold">
+                                          <p:stCondLst>
+                                            <p:cond delay="0"/>
+                                          </p:stCondLst>
+                                        </p:cTn>
+                                        <p:tgtEl>
+                                          <p:spTgt spid="8">
+                                            <p:txEl>
+                                              <p:pRg st="4" end="4"/>
+                                            </p:txEl>
+                                          </p:spTgt>
+                                        </p:tgtEl>
+                                        <p:attrNameLst>
+                                          <p:attrName>style.visibility</p:attrName>
+                                        </p:attrNameLst>
+                                      </p:cBhvr>
+                                      <p:to>
+                                        <p:strVal val="visible"/>
+                                      </p:to>
+                                    </p:set>
+                                    <p:animEffect transition="in" filter="fade">
+                                      <p:cBhvr>
+                                        <p:cTn id="41" dur="400"/>
+                                        <p:tgtEl>
+                                          <p:spTgt spid="8">
+                                            <p:txEl>
+                                              <p:pRg st="4" end="4"/>
+                                            </p:txEl>
+                                          </p:spTgt>
+                                        </p:tgtEl>
+                                      </p:cBhvr>
+                                    </p:animEffect>
+                                  </p:childTnLst>
+                                </p:cTn>
+                              </p:par>
+                            </p:childTnLst>
+                          </p:cTn>
+                        </p:par>
+                      </p:childTnLst>
+                    </p:cTn>
+                  </p:par>
+                  <p:par>
+                    <p:cTn id="42" fill="hold">
+                      <p:stCondLst>
+                        <p:cond delay="indefinite"/>
+                      </p:stCondLst>
+                      <p:childTnLst>
+                        <p:par>
+                          <p:cTn id="43" fill="hold">
+                            <p:stCondLst>
+                              <p:cond delay="0"/>
+                            </p:stCondLst>
+                            <p:childTnLst>
+                              <p:par>
+                                <p:cTn id="44" presetID="10" presetClass="entr" presetSubtype="0" fill="hold" grpId="0" nodeType="clickEffect">
+                                  <p:stCondLst>
+                                    <p:cond delay="0"/>
+                                  </p:stCondLst>
+                                  <p:childTnLst>
+                                    <p:set>
+                                      <p:cBhvr>
+                                        <p:cTn id="45" dur="1" fill="hold">
                                           <p:stCondLst>
                                             <p:cond delay="0"/>
                                           </p:stCondLst>
@@ -8536,7 +8936,7 @@
                                     </p:set>
                                     <p:animEffect transition="in" filter="fade">
                                       <p:cBhvr>
-                                        <p:cTn id="47" dur="400"/>
+                                        <p:cTn id="46" dur="400"/>
                                         <p:tgtEl>
                                           <p:spTgt spid="8">
                                             <p:txEl>
@@ -8546,6 +8946,44 @@
                                         </p:tgtEl>
                                       </p:cBhvr>
                                     </p:animEffect>
+                                  </p:childTnLst>
+                                </p:cTn>
+                              </p:par>
+                            </p:childTnLst>
+                          </p:cTn>
+                        </p:par>
+                      </p:childTnLst>
+                    </p:cTn>
+                  </p:par>
+                  <p:par>
+                    <p:cTn id="47" fill="hold">
+                      <p:stCondLst>
+                        <p:cond delay="0"/>
+                      </p:stCondLst>
+                      <p:childTnLst>
+                        <p:par>
+                          <p:cTn id="48" fill="hold">
+                            <p:stCondLst>
+                              <p:cond delay="0"/>
+                            </p:stCondLst>
+                            <p:childTnLst>
+                              <p:par>
+                                <p:cTn id="49" presetID="8" presetClass="emph" presetSubtype="0" fill="hold" grpId="0" nodeType="afterEffect">
+                                  <p:stCondLst>
+                                    <p:cond delay="0"/>
+                                  </p:stCondLst>
+                                  <p:childTnLst>
+                                    <p:animRot by="21600000">
+                                      <p:cBhvr>
+                                        <p:cTn id="50" dur="6000" repeatCount="indefinite" fill="hold"/>
+                                        <p:tgtEl>
+                                          <p:spTgt spid="6"/>
+                                        </p:tgtEl>
+                                        <p:attrNameLst>
+                                          <p:attrName>r</p:attrName>
+                                        </p:attrNameLst>
+                                      </p:cBhvr>
+                                    </p:animRot>
                                   </p:childTnLst>
                                 </p:cTn>
                               </p:par>
@@ -9404,7 +9842,7 @@
                             </p:stCondLst>
                             <p:childTnLst>
                               <p:par>
-                                <p:cTn id="36" presetID="53" presetClass="entr" presetSubtype="0" fill="hold" grpId="0" nodeType="afterEffect">
+                                <p:cTn id="36" presetID="22" presetClass="entr" presetSubtype="0" fill="hold" grpId="0" nodeType="afterEffect">
                                   <p:stCondLst>
                                     <p:cond delay="0"/>
                                   </p:stCondLst>
@@ -9427,24 +9865,14 @@
                                         <p:strVal val="visible"/>
                                       </p:to>
                                     </p:set>
-                                    <p:animEffect transition="in" filter="fade">
-                                      <p:cBhvr>
-                                        <p:cTn id="38" dur="600"/>
+                                    <p:animEffect transition="in" filter="wipe(up)">
+                                      <p:cBhvr>
+                                        <p:cTn id="38" dur="1600"/>
                                         <p:tgtEl>
                                           <p:spTgt spid="8"/>
                                         </p:tgtEl>
                                       </p:cBhvr>
                                     </p:animEffect>
-                                    <p:animScale>
-                                      <p:cBhvr>
-                                        <p:cTn id="39" dur="600" fill="hold"/>
-                                        <p:tgtEl>
-                                          <p:spTgt spid="8"/>
-                                        </p:tgtEl>
-                                      </p:cBhvr>
-                                      <p:from x="20000" y="20000"/>
-                                      <p:to x="100000" y="100000"/>
-                                    </p:animScale>
                                   </p:childTnLst>
                                 </p:cTn>
                               </p:par>
@@ -9455,26 +9883,26 @@
                     </p:cTn>
                   </p:par>
                   <p:par>
-                    <p:cTn id="40" fill="hold">
+                    <p:cTn id="39" fill="hold">
                       <p:stCondLst>
                         <p:cond delay="0"/>
                       </p:stCondLst>
                       <p:childTnLst>
                         <p:par>
-                          <p:cTn id="41" fill="hold">
+                          <p:cTn id="40" fill="hold">
                             <p:stCondLst>
                               <p:cond delay="0"/>
                             </p:stCondLst>
                             <p:childTnLst>
                               <p:par>
-                                <p:cTn id="42" presetID="10" presetClass="entr" presetSubtype="0" fill="hold" grpId="0" nodeType="afterEffect">
+                                <p:cTn id="41" presetID="10" presetClass="entr" presetSubtype="0" fill="hold" grpId="0" nodeType="afterEffect">
                                   <p:stCondLst>
                                     <p:cond delay="0"/>
                                   </p:stCondLst>
                                   <p:childTnLst>
                                     <p:set>
                                       <p:cBhvr>
-                                        <p:cTn id="43" dur="1" fill="hold">
+                                        <p:cTn id="42" dur="1" fill="hold">
                                           <p:stCondLst>
                                             <p:cond delay="0"/>
                                           </p:stCondLst>
@@ -9492,7 +9920,7 @@
                                     </p:set>
                                     <p:animEffect transition="in" filter="fade">
                                       <p:cBhvr>
-                                        <p:cTn id="44" dur="400"/>
+                                        <p:cTn id="43" dur="400"/>
                                         <p:tgtEl>
                                           <p:spTgt spid="9"/>
                                         </p:tgtEl>
@@ -10133,7 +10561,7 @@
                                 </p:cTn>
                               </p:par>
                               <p:par>
-                                <p:cTn id="14" presetID="53" presetClass="entr" presetSubtype="0" fill="hold" grpId="0" nodeType="withEffect">
+                                <p:cTn id="14" presetID="10" presetClass="entr" presetSubtype="0" fill="hold" grpId="0" nodeType="withEffect">
                                   <p:stCondLst>
                                     <p:cond delay="150"/>
                                   </p:stCondLst>
@@ -10161,77 +10589,6 @@
                                         <p:cTn id="16" dur="600"/>
                                         <p:tgtEl>
                                           <p:spTgt spid="7"/>
-                                        </p:tgtEl>
-                                      </p:cBhvr>
-                                    </p:animEffect>
-                                    <p:animScale>
-                                      <p:cBhvr>
-                                        <p:cTn id="17" dur="600" fill="hold"/>
-                                        <p:tgtEl>
-                                          <p:spTgt spid="7"/>
-                                        </p:tgtEl>
-                                      </p:cBhvr>
-                                      <p:from x="20000" y="20000"/>
-                                      <p:to x="100000" y="100000"/>
-                                    </p:animScale>
-                                  </p:childTnLst>
-                                </p:cTn>
-                              </p:par>
-                            </p:childTnLst>
-                          </p:cTn>
-                        </p:par>
-                      </p:childTnLst>
-                    </p:cTn>
-                  </p:par>
-                  <p:par>
-                    <p:cTn id="18" fill="hold">
-                      <p:stCondLst>
-                        <p:cond delay="indefinite"/>
-                      </p:stCondLst>
-                      <p:childTnLst>
-                        <p:par>
-                          <p:cTn id="19" fill="hold">
-                            <p:stCondLst>
-                              <p:cond delay="0"/>
-                            </p:stCondLst>
-                            <p:childTnLst>
-                              <p:par>
-                                <p:cTn id="20" presetID="10" presetClass="entr" presetSubtype="0" fill="hold" grpId="0" nodeType="clickEffect">
-                                  <p:stCondLst>
-                                    <p:cond delay="0"/>
-                                  </p:stCondLst>
-                                  <p:childTnLst>
-                                    <p:set>
-                                      <p:cBhvr>
-                                        <p:cTn id="21" dur="1" fill="hold">
-                                          <p:stCondLst>
-                                            <p:cond delay="0"/>
-                                          </p:stCondLst>
-                                        </p:cTn>
-                                        <p:tgtEl>
-                                          <p:spTgt spid="8">
-                                            <p:txEl>
-                                              <p:pRg st="0" end="0"/>
-                                            </p:txEl>
-                                          </p:spTgt>
-                                        </p:tgtEl>
-                                        <p:attrNameLst>
-                                          <p:attrName>style.visibility</p:attrName>
-                                        </p:attrNameLst>
-                                      </p:cBhvr>
-                                      <p:to>
-                                        <p:strVal val="visible"/>
-                                      </p:to>
-                                    </p:set>
-                                    <p:animEffect transition="in" filter="fade">
-                                      <p:cBhvr>
-                                        <p:cTn id="22" dur="400"/>
-                                        <p:tgtEl>
-                                          <p:spTgt spid="8">
-                                            <p:txEl>
-                                              <p:pRg st="0" end="0"/>
-                                            </p:txEl>
-                                          </p:spTgt>
                                         </p:tgtEl>
                                       </p:cBhvr>
                                     </p:animEffect>
@@ -10245,26 +10602,26 @@
                     </p:cTn>
                   </p:par>
                   <p:par>
-                    <p:cTn id="23" fill="hold">
+                    <p:cTn id="17" fill="hold">
                       <p:stCondLst>
                         <p:cond delay="indefinite"/>
                       </p:stCondLst>
                       <p:childTnLst>
                         <p:par>
-                          <p:cTn id="24" fill="hold">
+                          <p:cTn id="18" fill="hold">
                             <p:stCondLst>
                               <p:cond delay="0"/>
                             </p:stCondLst>
                             <p:childTnLst>
                               <p:par>
-                                <p:cTn id="25" presetID="10" presetClass="entr" presetSubtype="0" fill="hold" grpId="0" nodeType="clickEffect">
+                                <p:cTn id="19" presetID="10" presetClass="entr" presetSubtype="0" fill="hold" grpId="0" nodeType="clickEffect">
                                   <p:stCondLst>
                                     <p:cond delay="0"/>
                                   </p:stCondLst>
                                   <p:childTnLst>
                                     <p:set>
                                       <p:cBhvr>
-                                        <p:cTn id="26" dur="1" fill="hold">
+                                        <p:cTn id="20" dur="1" fill="hold">
                                           <p:stCondLst>
                                             <p:cond delay="0"/>
                                           </p:stCondLst>
@@ -10272,7 +10629,7 @@
                                         <p:tgtEl>
                                           <p:spTgt spid="8">
                                             <p:txEl>
-                                              <p:pRg st="1" end="1"/>
+                                              <p:pRg st="0" end="0"/>
                                             </p:txEl>
                                           </p:spTgt>
                                         </p:tgtEl>
@@ -10286,11 +10643,11 @@
                                     </p:set>
                                     <p:animEffect transition="in" filter="fade">
                                       <p:cBhvr>
-                                        <p:cTn id="27" dur="400"/>
+                                        <p:cTn id="21" dur="400"/>
                                         <p:tgtEl>
                                           <p:spTgt spid="8">
                                             <p:txEl>
-                                              <p:pRg st="1" end="1"/>
+                                              <p:pRg st="0" end="0"/>
                                             </p:txEl>
                                           </p:spTgt>
                                         </p:tgtEl>
@@ -10306,26 +10663,26 @@
                     </p:cTn>
                   </p:par>
                   <p:par>
-                    <p:cTn id="28" fill="hold">
+                    <p:cTn id="22" fill="hold">
                       <p:stCondLst>
                         <p:cond delay="indefinite"/>
                       </p:stCondLst>
                       <p:childTnLst>
                         <p:par>
-                          <p:cTn id="29" fill="hold">
+                          <p:cTn id="23" fill="hold">
                             <p:stCondLst>
                               <p:cond delay="0"/>
                             </p:stCondLst>
                             <p:childTnLst>
                               <p:par>
-                                <p:cTn id="30" presetID="10" presetClass="entr" presetSubtype="0" fill="hold" grpId="0" nodeType="clickEffect">
+                                <p:cTn id="24" presetID="10" presetClass="entr" presetSubtype="0" fill="hold" grpId="0" nodeType="clickEffect">
                                   <p:stCondLst>
                                     <p:cond delay="0"/>
                                   </p:stCondLst>
                                   <p:childTnLst>
                                     <p:set>
                                       <p:cBhvr>
-                                        <p:cTn id="31" dur="1" fill="hold">
+                                        <p:cTn id="25" dur="1" fill="hold">
                                           <p:stCondLst>
                                             <p:cond delay="0"/>
                                           </p:stCondLst>
@@ -10333,7 +10690,7 @@
                                         <p:tgtEl>
                                           <p:spTgt spid="8">
                                             <p:txEl>
-                                              <p:pRg st="2" end="2"/>
+                                              <p:pRg st="1" end="1"/>
                                             </p:txEl>
                                           </p:spTgt>
                                         </p:tgtEl>
@@ -10347,11 +10704,11 @@
                                     </p:set>
                                     <p:animEffect transition="in" filter="fade">
                                       <p:cBhvr>
-                                        <p:cTn id="32" dur="400"/>
+                                        <p:cTn id="26" dur="400"/>
                                         <p:tgtEl>
                                           <p:spTgt spid="8">
                                             <p:txEl>
-                                              <p:pRg st="2" end="2"/>
+                                              <p:pRg st="1" end="1"/>
                                             </p:txEl>
                                           </p:spTgt>
                                         </p:tgtEl>
@@ -10367,26 +10724,26 @@
                     </p:cTn>
                   </p:par>
                   <p:par>
-                    <p:cTn id="33" fill="hold">
+                    <p:cTn id="27" fill="hold">
                       <p:stCondLst>
                         <p:cond delay="indefinite"/>
                       </p:stCondLst>
                       <p:childTnLst>
                         <p:par>
-                          <p:cTn id="34" fill="hold">
+                          <p:cTn id="28" fill="hold">
                             <p:stCondLst>
                               <p:cond delay="0"/>
                             </p:stCondLst>
                             <p:childTnLst>
                               <p:par>
-                                <p:cTn id="35" presetID="10" presetClass="entr" presetSubtype="0" fill="hold" grpId="0" nodeType="clickEffect">
+                                <p:cTn id="29" presetID="10" presetClass="entr" presetSubtype="0" fill="hold" grpId="0" nodeType="clickEffect">
                                   <p:stCondLst>
                                     <p:cond delay="0"/>
                                   </p:stCondLst>
                                   <p:childTnLst>
                                     <p:set>
                                       <p:cBhvr>
-                                        <p:cTn id="36" dur="1" fill="hold">
+                                        <p:cTn id="30" dur="1" fill="hold">
                                           <p:stCondLst>
                                             <p:cond delay="0"/>
                                           </p:stCondLst>
@@ -10394,7 +10751,7 @@
                                         <p:tgtEl>
                                           <p:spTgt spid="8">
                                             <p:txEl>
-                                              <p:pRg st="3" end="3"/>
+                                              <p:pRg st="2" end="2"/>
                                             </p:txEl>
                                           </p:spTgt>
                                         </p:tgtEl>
@@ -10408,11 +10765,11 @@
                                     </p:set>
                                     <p:animEffect transition="in" filter="fade">
                                       <p:cBhvr>
-                                        <p:cTn id="37" dur="400"/>
+                                        <p:cTn id="31" dur="400"/>
                                         <p:tgtEl>
                                           <p:spTgt spid="8">
                                             <p:txEl>
-                                              <p:pRg st="3" end="3"/>
+                                              <p:pRg st="2" end="2"/>
                                             </p:txEl>
                                           </p:spTgt>
                                         </p:tgtEl>
@@ -10428,26 +10785,26 @@
                     </p:cTn>
                   </p:par>
                   <p:par>
-                    <p:cTn id="38" fill="hold">
+                    <p:cTn id="32" fill="hold">
                       <p:stCondLst>
                         <p:cond delay="indefinite"/>
                       </p:stCondLst>
                       <p:childTnLst>
                         <p:par>
-                          <p:cTn id="39" fill="hold">
+                          <p:cTn id="33" fill="hold">
                             <p:stCondLst>
                               <p:cond delay="0"/>
                             </p:stCondLst>
                             <p:childTnLst>
                               <p:par>
-                                <p:cTn id="40" presetID="10" presetClass="entr" presetSubtype="0" fill="hold" grpId="0" nodeType="clickEffect">
+                                <p:cTn id="34" presetID="10" presetClass="entr" presetSubtype="0" fill="hold" grpId="0" nodeType="clickEffect">
                                   <p:stCondLst>
                                     <p:cond delay="0"/>
                                   </p:stCondLst>
                                   <p:childTnLst>
                                     <p:set>
                                       <p:cBhvr>
-                                        <p:cTn id="41" dur="1" fill="hold">
+                                        <p:cTn id="35" dur="1" fill="hold">
                                           <p:stCondLst>
                                             <p:cond delay="0"/>
                                           </p:stCondLst>
@@ -10455,7 +10812,7 @@
                                         <p:tgtEl>
                                           <p:spTgt spid="8">
                                             <p:txEl>
-                                              <p:pRg st="4" end="4"/>
+                                              <p:pRg st="3" end="3"/>
                                             </p:txEl>
                                           </p:spTgt>
                                         </p:tgtEl>
@@ -10469,11 +10826,11 @@
                                     </p:set>
                                     <p:animEffect transition="in" filter="fade">
                                       <p:cBhvr>
-                                        <p:cTn id="42" dur="400"/>
+                                        <p:cTn id="36" dur="400"/>
                                         <p:tgtEl>
                                           <p:spTgt spid="8">
                                             <p:txEl>
-                                              <p:pRg st="4" end="4"/>
+                                              <p:pRg st="3" end="3"/>
                                             </p:txEl>
                                           </p:spTgt>
                                         </p:tgtEl>
@@ -10489,26 +10846,87 @@
                     </p:cTn>
                   </p:par>
                   <p:par>
-                    <p:cTn id="43" fill="hold">
+                    <p:cTn id="37" fill="hold">
                       <p:stCondLst>
                         <p:cond delay="indefinite"/>
                       </p:stCondLst>
                       <p:childTnLst>
                         <p:par>
-                          <p:cTn id="44" fill="hold">
+                          <p:cTn id="38" fill="hold">
                             <p:stCondLst>
                               <p:cond delay="0"/>
                             </p:stCondLst>
                             <p:childTnLst>
                               <p:par>
-                                <p:cTn id="45" presetID="10" presetClass="entr" presetSubtype="0" fill="hold" grpId="0" nodeType="clickEffect">
+                                <p:cTn id="39" presetID="10" presetClass="entr" presetSubtype="0" fill="hold" grpId="0" nodeType="clickEffect">
                                   <p:stCondLst>
                                     <p:cond delay="0"/>
                                   </p:stCondLst>
                                   <p:childTnLst>
                                     <p:set>
                                       <p:cBhvr>
-                                        <p:cTn id="46" dur="1" fill="hold">
+                                        <p:cTn id="40" dur="1" fill="hold">
+                                          <p:stCondLst>
+                                            <p:cond delay="0"/>
+                                          </p:stCondLst>
+                                        </p:cTn>
+                                        <p:tgtEl>
+                                          <p:spTgt spid="8">
+                                            <p:txEl>
+                                              <p:pRg st="4" end="4"/>
+                                            </p:txEl>
+                                          </p:spTgt>
+                                        </p:tgtEl>
+                                        <p:attrNameLst>
+                                          <p:attrName>style.visibility</p:attrName>
+                                        </p:attrNameLst>
+                                      </p:cBhvr>
+                                      <p:to>
+                                        <p:strVal val="visible"/>
+                                      </p:to>
+                                    </p:set>
+                                    <p:animEffect transition="in" filter="fade">
+                                      <p:cBhvr>
+                                        <p:cTn id="41" dur="400"/>
+                                        <p:tgtEl>
+                                          <p:spTgt spid="8">
+                                            <p:txEl>
+                                              <p:pRg st="4" end="4"/>
+                                            </p:txEl>
+                                          </p:spTgt>
+                                        </p:tgtEl>
+                                      </p:cBhvr>
+                                    </p:animEffect>
+                                  </p:childTnLst>
+                                </p:cTn>
+                              </p:par>
+                            </p:childTnLst>
+                          </p:cTn>
+                        </p:par>
+                      </p:childTnLst>
+                    </p:cTn>
+                  </p:par>
+                  <p:par>
+                    <p:cTn id="42" fill="hold">
+                      <p:stCondLst>
+                        <p:cond delay="indefinite"/>
+                      </p:stCondLst>
+                      <p:childTnLst>
+                        <p:par>
+                          <p:cTn id="43" fill="hold">
+                            <p:stCondLst>
+                              <p:cond delay="0"/>
+                            </p:stCondLst>
+                            <p:childTnLst>
+                              <p:par>
+                                <p:cTn id="44" presetID="10" presetClass="entr" presetSubtype="0" fill="hold" grpId="0" nodeType="clickEffect">
+                                  <p:stCondLst>
+                                    <p:cond delay="0"/>
+                                  </p:stCondLst>
+                                  <p:childTnLst>
+                                    <p:set>
+                                      <p:cBhvr>
+                                        <p:cTn id="45" dur="1" fill="hold">
                                           <p:stCondLst>
                                             <p:cond delay="0"/>
                                           </p:stCondLst>
@@ -10530,7 +10948,7 @@
                                     </p:set>
                                     <p:animEffect transition="in" filter="fade">
                                       <p:cBhvr>
-                                        <p:cTn id="47" dur="400"/>
+                                        <p:cTn id="46" dur="400"/>
                                         <p:tgtEl>
                                           <p:spTgt spid="8">
                                             <p:txEl>
@@ -11017,6 +11435,30 @@
           </a:p>
         </p:txBody>
       </p:sp>
+      <p:pic>
+        <p:nvPicPr>
+          <p:cNvPr id="8" name="Picture 7" descr="horse.png"/>
+          <p:cNvPicPr>
+            <a:picLocks noChangeAspect="1"/>
+          </p:cNvPicPr>
+          <p:nvPr/>
+        </p:nvPicPr>
+        <p:blipFill>
+          <a:blip r:embed="rId2"/>
+          <a:stretch>
+            <a:fillRect/>
+          </a:stretch>
+        </p:blipFill>
+        <p:spPr>
+          <a:xfrm>
+            <a:off x="-1481328" y="4663440"/>
+            <a:ext cx="1234440" cy="954770"/>
+          </a:xfrm>
+          <a:prstGeom prst="rect">
+            <a:avLst/>
+          </a:prstGeom>
+        </p:spPr>
+      </p:pic>
     </p:spTree>
   </p:cSld>
   <p:clrMapOvr>
@@ -11506,6 +11948,81 @@
                                       <p:from x="20000" y="20000"/>
                                       <p:to x="100000" y="100000"/>
                                     </p:animScale>
+                                  </p:childTnLst>
+                                </p:cTn>
+                              </p:par>
+                            </p:childTnLst>
+                          </p:cTn>
+                        </p:par>
+                      </p:childTnLst>
+                    </p:cTn>
+                  </p:par>
+                  <p:par>
+                    <p:cTn id="44" fill="hold">
+                      <p:stCondLst>
+                        <p:cond delay="0"/>
+                      </p:stCondLst>
+                      <p:childTnLst>
+                        <p:par>
+                          <p:cTn id="45" fill="hold">
+                            <p:stCondLst>
+                              <p:cond delay="0"/>
+                            </p:stCondLst>
+                            <p:childTnLst>
+                              <p:par>
+                                <p:cTn id="46" presetID="26" presetClass="emph" presetSubtype="0" fill="hold" grpId="0" nodeType="afterEffect">
+                                  <p:stCondLst>
+                                    <p:cond delay="0"/>
+                                  </p:stCondLst>
+                                  <p:childTnLst>
+                                    <p:animScale>
+                                      <p:cBhvr>
+                                        <p:cTn id="47" dur="800" autoRev="1" repeatCount="3000" fill="hold"/>
+                                        <p:tgtEl>
+                                          <p:spTgt spid="7"/>
+                                        </p:tgtEl>
+                                      </p:cBhvr>
+                                      <p:by x="110000" y="110000"/>
+                                    </p:animScale>
+                                  </p:childTnLst>
+                                </p:cTn>
+                              </p:par>
+                            </p:childTnLst>
+                          </p:cTn>
+                        </p:par>
+                      </p:childTnLst>
+                    </p:cTn>
+                  </p:par>
+                  <p:par>
+                    <p:cTn id="48" fill="hold">
+                      <p:stCondLst>
+                        <p:cond delay="0"/>
+                      </p:stCondLst>
+                      <p:childTnLst>
+                        <p:par>
+                          <p:cTn id="49" fill="hold">
+                            <p:stCondLst>
+                              <p:cond delay="0"/>
+                            </p:stCondLst>
+                            <p:childTnLst>
+                              <p:par>
+                                <p:cTn id="50" presetID="0" presetClass="path" presetSubtype="0" fill="hold" grpId="0" nodeType="afterEffect">
+                                  <p:stCondLst>
+                                    <p:cond delay="0"/>
+                                  </p:stCondLst>
+                                  <p:childTnLst>
+                                    <p:animMotion origin="layout" path="M 0 0 L 0.1 -0.015 L 0.2 0 L 0.3 -0.015 L 0.4 0 L 0.5 -0.015 L 0.6 0 L 0.7 -0.015 L 0.8 0 L 0.9 -0.015 L 1.0 0 L 1.18 0 E" pathEditMode="relative" ptsTypes="">
+                                      <p:cBhvr>
+                                        <p:cTn id="51" dur="6000" repeatCount="indefinite" fill="hold"/>
+                                        <p:tgtEl>
+                                          <p:spTgt spid="8"/>
+                                        </p:tgtEl>
+                                        <p:attrNameLst>
+                                          <p:attrName>ppt_x</p:attrName>
+                                          <p:attrName>ppt_y</p:attrName>
+                                        </p:attrNameLst>
+                                      </p:cBhvr>
+                                    </p:animMotion>
                                   </p:childTnLst>
                                 </p:cTn>
                               </p:par>
@@ -12888,7 +13405,7 @@
                                 </p:cTn>
                               </p:par>
                               <p:par>
-                                <p:cTn id="14" presetID="53" presetClass="entr" presetSubtype="0" fill="hold" grpId="0" nodeType="withEffect">
+                                <p:cTn id="14" presetID="10" presetClass="entr" presetSubtype="0" fill="hold" grpId="0" nodeType="withEffect">
                                   <p:stCondLst>
                                     <p:cond delay="150"/>
                                   </p:stCondLst>
@@ -12916,77 +13433,6 @@
                                         <p:cTn id="16" dur="600"/>
                                         <p:tgtEl>
                                           <p:spTgt spid="7"/>
-                                        </p:tgtEl>
-                                      </p:cBhvr>
-                                    </p:animEffect>
-                                    <p:animScale>
-                                      <p:cBhvr>
-                                        <p:cTn id="17" dur="600" fill="hold"/>
-                                        <p:tgtEl>
-                                          <p:spTgt spid="7"/>
-                                        </p:tgtEl>
-                                      </p:cBhvr>
-                                      <p:from x="20000" y="20000"/>
-                                      <p:to x="100000" y="100000"/>
-                                    </p:animScale>
-                                  </p:childTnLst>
-                                </p:cTn>
-                              </p:par>
-                            </p:childTnLst>
-                          </p:cTn>
-                        </p:par>
-                      </p:childTnLst>
-                    </p:cTn>
-                  </p:par>
-                  <p:par>
-                    <p:cTn id="18" fill="hold">
-                      <p:stCondLst>
-                        <p:cond delay="indefinite"/>
-                      </p:stCondLst>
-                      <p:childTnLst>
-                        <p:par>
-                          <p:cTn id="19" fill="hold">
-                            <p:stCondLst>
-                              <p:cond delay="0"/>
-                            </p:stCondLst>
-                            <p:childTnLst>
-                              <p:par>
-                                <p:cTn id="20" presetID="10" presetClass="entr" presetSubtype="0" fill="hold" grpId="0" nodeType="clickEffect">
-                                  <p:stCondLst>
-                                    <p:cond delay="0"/>
-                                  </p:stCondLst>
-                                  <p:childTnLst>
-                                    <p:set>
-                                      <p:cBhvr>
-                                        <p:cTn id="21" dur="1" fill="hold">
-                                          <p:stCondLst>
-                                            <p:cond delay="0"/>
-                                          </p:stCondLst>
-                                        </p:cTn>
-                                        <p:tgtEl>
-                                          <p:spTgt spid="8">
-                                            <p:txEl>
-                                              <p:pRg st="0" end="0"/>
-                                            </p:txEl>
-                                          </p:spTgt>
-                                        </p:tgtEl>
-                                        <p:attrNameLst>
-                                          <p:attrName>style.visibility</p:attrName>
-                                        </p:attrNameLst>
-                                      </p:cBhvr>
-                                      <p:to>
-                                        <p:strVal val="visible"/>
-                                      </p:to>
-                                    </p:set>
-                                    <p:animEffect transition="in" filter="fade">
-                                      <p:cBhvr>
-                                        <p:cTn id="22" dur="400"/>
-                                        <p:tgtEl>
-                                          <p:spTgt spid="8">
-                                            <p:txEl>
-                                              <p:pRg st="0" end="0"/>
-                                            </p:txEl>
-                                          </p:spTgt>
                                         </p:tgtEl>
                                       </p:cBhvr>
                                     </p:animEffect>
@@ -13000,26 +13446,26 @@
                     </p:cTn>
                   </p:par>
                   <p:par>
-                    <p:cTn id="23" fill="hold">
+                    <p:cTn id="17" fill="hold">
                       <p:stCondLst>
                         <p:cond delay="indefinite"/>
                       </p:stCondLst>
                       <p:childTnLst>
                         <p:par>
-                          <p:cTn id="24" fill="hold">
+                          <p:cTn id="18" fill="hold">
                             <p:stCondLst>
                               <p:cond delay="0"/>
                             </p:stCondLst>
                             <p:childTnLst>
                               <p:par>
-                                <p:cTn id="25" presetID="10" presetClass="entr" presetSubtype="0" fill="hold" grpId="0" nodeType="clickEffect">
+                                <p:cTn id="19" presetID="10" presetClass="entr" presetSubtype="0" fill="hold" grpId="0" nodeType="clickEffect">
                                   <p:stCondLst>
                                     <p:cond delay="0"/>
                                   </p:stCondLst>
                                   <p:childTnLst>
                                     <p:set>
                                       <p:cBhvr>
-                                        <p:cTn id="26" dur="1" fill="hold">
+                                        <p:cTn id="20" dur="1" fill="hold">
                                           <p:stCondLst>
                                             <p:cond delay="0"/>
                                           </p:stCondLst>
@@ -13027,7 +13473,7 @@
                                         <p:tgtEl>
                                           <p:spTgt spid="8">
                                             <p:txEl>
-                                              <p:pRg st="1" end="1"/>
+                                              <p:pRg st="0" end="0"/>
                                             </p:txEl>
                                           </p:spTgt>
                                         </p:tgtEl>
@@ -13041,11 +13487,11 @@
                                     </p:set>
                                     <p:animEffect transition="in" filter="fade">
                                       <p:cBhvr>
-                                        <p:cTn id="27" dur="400"/>
+                                        <p:cTn id="21" dur="400"/>
                                         <p:tgtEl>
                                           <p:spTgt spid="8">
                                             <p:txEl>
-                                              <p:pRg st="1" end="1"/>
+                                              <p:pRg st="0" end="0"/>
                                             </p:txEl>
                                           </p:spTgt>
                                         </p:tgtEl>
@@ -13061,26 +13507,26 @@
                     </p:cTn>
                   </p:par>
                   <p:par>
-                    <p:cTn id="28" fill="hold">
+                    <p:cTn id="22" fill="hold">
                       <p:stCondLst>
                         <p:cond delay="indefinite"/>
                       </p:stCondLst>
                       <p:childTnLst>
                         <p:par>
-                          <p:cTn id="29" fill="hold">
+                          <p:cTn id="23" fill="hold">
                             <p:stCondLst>
                               <p:cond delay="0"/>
                             </p:stCondLst>
                             <p:childTnLst>
                               <p:par>
-                                <p:cTn id="30" presetID="10" presetClass="entr" presetSubtype="0" fill="hold" grpId="0" nodeType="clickEffect">
+                                <p:cTn id="24" presetID="10" presetClass="entr" presetSubtype="0" fill="hold" grpId="0" nodeType="clickEffect">
                                   <p:stCondLst>
                                     <p:cond delay="0"/>
                                   </p:stCondLst>
                                   <p:childTnLst>
                                     <p:set>
                                       <p:cBhvr>
-                                        <p:cTn id="31" dur="1" fill="hold">
+                                        <p:cTn id="25" dur="1" fill="hold">
                                           <p:stCondLst>
                                             <p:cond delay="0"/>
                                           </p:stCondLst>
@@ -13088,7 +13534,7 @@
                                         <p:tgtEl>
                                           <p:spTgt spid="8">
                                             <p:txEl>
-                                              <p:pRg st="2" end="2"/>
+                                              <p:pRg st="1" end="1"/>
                                             </p:txEl>
                                           </p:spTgt>
                                         </p:tgtEl>
@@ -13102,11 +13548,11 @@
                                     </p:set>
                                     <p:animEffect transition="in" filter="fade">
                                       <p:cBhvr>
-                                        <p:cTn id="32" dur="400"/>
+                                        <p:cTn id="26" dur="400"/>
                                         <p:tgtEl>
                                           <p:spTgt spid="8">
                                             <p:txEl>
-                                              <p:pRg st="2" end="2"/>
+                                              <p:pRg st="1" end="1"/>
                                             </p:txEl>
                                           </p:spTgt>
                                         </p:tgtEl>
@@ -13122,26 +13568,26 @@
                     </p:cTn>
                   </p:par>
                   <p:par>
-                    <p:cTn id="33" fill="hold">
+                    <p:cTn id="27" fill="hold">
                       <p:stCondLst>
                         <p:cond delay="indefinite"/>
                       </p:stCondLst>
                       <p:childTnLst>
                         <p:par>
-                          <p:cTn id="34" fill="hold">
+                          <p:cTn id="28" fill="hold">
                             <p:stCondLst>
                               <p:cond delay="0"/>
                             </p:stCondLst>
                             <p:childTnLst>
                               <p:par>
-                                <p:cTn id="35" presetID="10" presetClass="entr" presetSubtype="0" fill="hold" grpId="0" nodeType="clickEffect">
+                                <p:cTn id="29" presetID="10" presetClass="entr" presetSubtype="0" fill="hold" grpId="0" nodeType="clickEffect">
                                   <p:stCondLst>
                                     <p:cond delay="0"/>
                                   </p:stCondLst>
                                   <p:childTnLst>
                                     <p:set>
                                       <p:cBhvr>
-                                        <p:cTn id="36" dur="1" fill="hold">
+                                        <p:cTn id="30" dur="1" fill="hold">
                                           <p:stCondLst>
                                             <p:cond delay="0"/>
                                           </p:stCondLst>
@@ -13149,7 +13595,7 @@
                                         <p:tgtEl>
                                           <p:spTgt spid="8">
                                             <p:txEl>
-                                              <p:pRg st="3" end="3"/>
+                                              <p:pRg st="2" end="2"/>
                                             </p:txEl>
                                           </p:spTgt>
                                         </p:tgtEl>
@@ -13163,11 +13609,11 @@
                                     </p:set>
                                     <p:animEffect transition="in" filter="fade">
                                       <p:cBhvr>
-                                        <p:cTn id="37" dur="400"/>
+                                        <p:cTn id="31" dur="400"/>
                                         <p:tgtEl>
                                           <p:spTgt spid="8">
                                             <p:txEl>
-                                              <p:pRg st="3" end="3"/>
+                                              <p:pRg st="2" end="2"/>
                                             </p:txEl>
                                           </p:spTgt>
                                         </p:tgtEl>
@@ -13183,26 +13629,87 @@
                     </p:cTn>
                   </p:par>
                   <p:par>
-                    <p:cTn id="38" fill="hold">
+                    <p:cTn id="32" fill="hold">
                       <p:stCondLst>
                         <p:cond delay="indefinite"/>
                       </p:stCondLst>
                       <p:childTnLst>
                         <p:par>
-                          <p:cTn id="39" fill="hold">
+                          <p:cTn id="33" fill="hold">
                             <p:stCondLst>
                               <p:cond delay="0"/>
                             </p:stCondLst>
                             <p:childTnLst>
                               <p:par>
-                                <p:cTn id="40" presetID="10" presetClass="entr" presetSubtype="0" fill="hold" grpId="0" nodeType="clickEffect">
+                                <p:cTn id="34" presetID="10" presetClass="entr" presetSubtype="0" fill="hold" grpId="0" nodeType="clickEffect">
                                   <p:stCondLst>
                                     <p:cond delay="0"/>
                                   </p:stCondLst>
                                   <p:childTnLst>
                                     <p:set>
                                       <p:cBhvr>
-                                        <p:cTn id="41" dur="1" fill="hold">
+                                        <p:cTn id="35" dur="1" fill="hold">
+                                          <p:stCondLst>
+                                            <p:cond delay="0"/>
+                                          </p:stCondLst>
+                                        </p:cTn>
+                                        <p:tgtEl>
+                                          <p:spTgt spid="8">
+                                            <p:txEl>
+                                              <p:pRg st="3" end="3"/>
+                                            </p:txEl>
+                                          </p:spTgt>
+                                        </p:tgtEl>
+                                        <p:attrNameLst>
+                                          <p:attrName>style.visibility</p:attrName>
+                                        </p:attrNameLst>
+                                      </p:cBhvr>
+                                      <p:to>
+                                        <p:strVal val="visible"/>
+                                      </p:to>
+                                    </p:set>
+                                    <p:animEffect transition="in" filter="fade">
+                                      <p:cBhvr>
+                                        <p:cTn id="36" dur="400"/>
+                                        <p:tgtEl>
+                                          <p:spTgt spid="8">
+                                            <p:txEl>
+                                              <p:pRg st="3" end="3"/>
+                                            </p:txEl>
+                                          </p:spTgt>
+                                        </p:tgtEl>
+                                      </p:cBhvr>
+                                    </p:animEffect>
+                                  </p:childTnLst>
+                                </p:cTn>
+                              </p:par>
+                            </p:childTnLst>
+                          </p:cTn>
+                        </p:par>
+                      </p:childTnLst>
+                    </p:cTn>
+                  </p:par>
+                  <p:par>
+                    <p:cTn id="37" fill="hold">
+                      <p:stCondLst>
+                        <p:cond delay="indefinite"/>
+                      </p:stCondLst>
+                      <p:childTnLst>
+                        <p:par>
+                          <p:cTn id="38" fill="hold">
+                            <p:stCondLst>
+                              <p:cond delay="0"/>
+                            </p:stCondLst>
+                            <p:childTnLst>
+                              <p:par>
+                                <p:cTn id="39" presetID="10" presetClass="entr" presetSubtype="0" fill="hold" grpId="0" nodeType="clickEffect">
+                                  <p:stCondLst>
+                                    <p:cond delay="0"/>
+                                  </p:stCondLst>
+                                  <p:childTnLst>
+                                    <p:set>
+                                      <p:cBhvr>
+                                        <p:cTn id="40" dur="1" fill="hold">
                                           <p:stCondLst>
                                             <p:cond delay="0"/>
                                           </p:stCondLst>
@@ -13224,7 +13731,7 @@
                                     </p:set>
                                     <p:animEffect transition="in" filter="fade">
                                       <p:cBhvr>
-                                        <p:cTn id="42" dur="400"/>
+                                        <p:cTn id="41" dur="400"/>
                                         <p:tgtEl>
                                           <p:spTgt spid="8">
                                             <p:txEl>
@@ -14514,6 +15021,30 @@
           </a:p>
         </p:txBody>
       </p:sp>
+      <p:pic>
+        <p:nvPicPr>
+          <p:cNvPr id="21" name="Picture 20" descr="horse.png"/>
+          <p:cNvPicPr>
+            <a:picLocks noChangeAspect="1"/>
+          </p:cNvPicPr>
+          <p:nvPr/>
+        </p:nvPicPr>
+        <p:blipFill>
+          <a:blip r:embed="rId2"/>
+          <a:stretch>
+            <a:fillRect/>
+          </a:stretch>
+        </p:blipFill>
+        <p:spPr>
+          <a:xfrm>
+            <a:off x="-1261872" y="2907792"/>
+            <a:ext cx="1051560" cy="813322"/>
+          </a:xfrm>
+          <a:prstGeom prst="rect">
+            <a:avLst/>
+          </a:prstGeom>
+        </p:spPr>
+      </p:pic>
     </p:spTree>
   </p:cSld>
   <p:clrMapOvr>
@@ -15205,6 +15736,45 @@
                                       <p:from x="20000" y="20000"/>
                                       <p:to x="100000" y="100000"/>
                                     </p:animScale>
+                                  </p:childTnLst>
+                                </p:cTn>
+                              </p:par>
+                            </p:childTnLst>
+                          </p:cTn>
+                        </p:par>
+                      </p:childTnLst>
+                    </p:cTn>
+                  </p:par>
+                  <p:par>
+                    <p:cTn id="64" fill="hold">
+                      <p:stCondLst>
+                        <p:cond delay="0"/>
+                      </p:stCondLst>
+                      <p:childTnLst>
+                        <p:par>
+                          <p:cTn id="65" fill="hold">
+                            <p:stCondLst>
+                              <p:cond delay="0"/>
+                            </p:stCondLst>
+                            <p:childTnLst>
+                              <p:par>
+                                <p:cTn id="66" presetID="0" presetClass="path" presetSubtype="0" fill="hold" grpId="0" nodeType="afterEffect">
+                                  <p:stCondLst>
+                                    <p:cond delay="0"/>
+                                  </p:stCondLst>
+                                  <p:childTnLst>
+                                    <p:animMotion origin="layout" path="M 0 0 L 0.1 -0.015 L 0.2 0 L 0.3 -0.015 L 0.4 0 L 0.5 -0.015 L 0.6 0 L 0.7 -0.015 L 0.8 0 L 0.9 -0.015 L 1.0 0 L 1.18 0 E" pathEditMode="relative" ptsTypes="">
+                                      <p:cBhvr>
+                                        <p:cTn id="67" dur="5500" repeatCount="indefinite" fill="hold"/>
+                                        <p:tgtEl>
+                                          <p:spTgt spid="21"/>
+                                        </p:tgtEl>
+                                        <p:attrNameLst>
+                                          <p:attrName>ppt_x</p:attrName>
+                                          <p:attrName>ppt_y</p:attrName>
+                                        </p:attrNameLst>
+                                      </p:cBhvr>
+                                    </p:animMotion>
                                   </p:childTnLst>
                                 </p:cTn>
                               </p:par>
@@ -15817,7 +16387,7 @@
                                 </p:cTn>
                               </p:par>
                               <p:par>
-                                <p:cTn id="14" presetID="53" presetClass="entr" presetSubtype="0" fill="hold" grpId="0" nodeType="withEffect">
+                                <p:cTn id="14" presetID="10" presetClass="entr" presetSubtype="0" fill="hold" grpId="0" nodeType="withEffect">
                                   <p:stCondLst>
                                     <p:cond delay="150"/>
                                   </p:stCondLst>
@@ -15845,77 +16415,6 @@
                                         <p:cTn id="16" dur="600"/>
                                         <p:tgtEl>
                                           <p:spTgt spid="7"/>
-                                        </p:tgtEl>
-                                      </p:cBhvr>
-                                    </p:animEffect>
-                                    <p:animScale>
-                                      <p:cBhvr>
-                                        <p:cTn id="17" dur="600" fill="hold"/>
-                                        <p:tgtEl>
-                                          <p:spTgt spid="7"/>
-                                        </p:tgtEl>
-                                      </p:cBhvr>
-                                      <p:from x="20000" y="20000"/>
-                                      <p:to x="100000" y="100000"/>
-                                    </p:animScale>
-                                  </p:childTnLst>
-                                </p:cTn>
-                              </p:par>
-                            </p:childTnLst>
-                          </p:cTn>
-                        </p:par>
-                      </p:childTnLst>
-                    </p:cTn>
-                  </p:par>
-                  <p:par>
-                    <p:cTn id="18" fill="hold">
-                      <p:stCondLst>
-                        <p:cond delay="indefinite"/>
-                      </p:stCondLst>
-                      <p:childTnLst>
-                        <p:par>
-                          <p:cTn id="19" fill="hold">
-                            <p:stCondLst>
-                              <p:cond delay="0"/>
-                            </p:stCondLst>
-                            <p:childTnLst>
-                              <p:par>
-                                <p:cTn id="20" presetID="10" presetClass="entr" presetSubtype="0" fill="hold" grpId="0" nodeType="clickEffect">
-                                  <p:stCondLst>
-                                    <p:cond delay="0"/>
-                                  </p:stCondLst>
-                                  <p:childTnLst>
-                                    <p:set>
-                                      <p:cBhvr>
-                                        <p:cTn id="21" dur="1" fill="hold">
-                                          <p:stCondLst>
-                                            <p:cond delay="0"/>
-                                          </p:stCondLst>
-                                        </p:cTn>
-                                        <p:tgtEl>
-                                          <p:spTgt spid="8">
-                                            <p:txEl>
-                                              <p:pRg st="0" end="0"/>
-                                            </p:txEl>
-                                          </p:spTgt>
-                                        </p:tgtEl>
-                                        <p:attrNameLst>
-                                          <p:attrName>style.visibility</p:attrName>
-                                        </p:attrNameLst>
-                                      </p:cBhvr>
-                                      <p:to>
-                                        <p:strVal val="visible"/>
-                                      </p:to>
-                                    </p:set>
-                                    <p:animEffect transition="in" filter="fade">
-                                      <p:cBhvr>
-                                        <p:cTn id="22" dur="400"/>
-                                        <p:tgtEl>
-                                          <p:spTgt spid="8">
-                                            <p:txEl>
-                                              <p:pRg st="0" end="0"/>
-                                            </p:txEl>
-                                          </p:spTgt>
                                         </p:tgtEl>
                                       </p:cBhvr>
                                     </p:animEffect>
@@ -15929,26 +16428,26 @@
                     </p:cTn>
                   </p:par>
                   <p:par>
-                    <p:cTn id="23" fill="hold">
+                    <p:cTn id="17" fill="hold">
                       <p:stCondLst>
                         <p:cond delay="indefinite"/>
                       </p:stCondLst>
                       <p:childTnLst>
                         <p:par>
-                          <p:cTn id="24" fill="hold">
+                          <p:cTn id="18" fill="hold">
                             <p:stCondLst>
                               <p:cond delay="0"/>
                             </p:stCondLst>
                             <p:childTnLst>
                               <p:par>
-                                <p:cTn id="25" presetID="10" presetClass="entr" presetSubtype="0" fill="hold" grpId="0" nodeType="clickEffect">
+                                <p:cTn id="19" presetID="10" presetClass="entr" presetSubtype="0" fill="hold" grpId="0" nodeType="clickEffect">
                                   <p:stCondLst>
                                     <p:cond delay="0"/>
                                   </p:stCondLst>
                                   <p:childTnLst>
                                     <p:set>
                                       <p:cBhvr>
-                                        <p:cTn id="26" dur="1" fill="hold">
+                                        <p:cTn id="20" dur="1" fill="hold">
                                           <p:stCondLst>
                                             <p:cond delay="0"/>
                                           </p:stCondLst>
@@ -15956,7 +16455,7 @@
                                         <p:tgtEl>
                                           <p:spTgt spid="8">
                                             <p:txEl>
-                                              <p:pRg st="1" end="1"/>
+                                              <p:pRg st="0" end="0"/>
                                             </p:txEl>
                                           </p:spTgt>
                                         </p:tgtEl>
@@ -15970,11 +16469,11 @@
                                     </p:set>
                                     <p:animEffect transition="in" filter="fade">
                                       <p:cBhvr>
-                                        <p:cTn id="27" dur="400"/>
+                                        <p:cTn id="21" dur="400"/>
                                         <p:tgtEl>
                                           <p:spTgt spid="8">
                                             <p:txEl>
-                                              <p:pRg st="1" end="1"/>
+                                              <p:pRg st="0" end="0"/>
                                             </p:txEl>
                                           </p:spTgt>
                                         </p:tgtEl>
@@ -15990,26 +16489,26 @@
                     </p:cTn>
                   </p:par>
                   <p:par>
-                    <p:cTn id="28" fill="hold">
+                    <p:cTn id="22" fill="hold">
                       <p:stCondLst>
                         <p:cond delay="indefinite"/>
                       </p:stCondLst>
                       <p:childTnLst>
                         <p:par>
-                          <p:cTn id="29" fill="hold">
+                          <p:cTn id="23" fill="hold">
                             <p:stCondLst>
                               <p:cond delay="0"/>
                             </p:stCondLst>
                             <p:childTnLst>
                               <p:par>
-                                <p:cTn id="30" presetID="10" presetClass="entr" presetSubtype="0" fill="hold" grpId="0" nodeType="clickEffect">
+                                <p:cTn id="24" presetID="10" presetClass="entr" presetSubtype="0" fill="hold" grpId="0" nodeType="clickEffect">
                                   <p:stCondLst>
                                     <p:cond delay="0"/>
                                   </p:stCondLst>
                                   <p:childTnLst>
                                     <p:set>
                                       <p:cBhvr>
-                                        <p:cTn id="31" dur="1" fill="hold">
+                                        <p:cTn id="25" dur="1" fill="hold">
                                           <p:stCondLst>
                                             <p:cond delay="0"/>
                                           </p:stCondLst>
@@ -16017,7 +16516,7 @@
                                         <p:tgtEl>
                                           <p:spTgt spid="8">
                                             <p:txEl>
-                                              <p:pRg st="2" end="2"/>
+                                              <p:pRg st="1" end="1"/>
                                             </p:txEl>
                                           </p:spTgt>
                                         </p:tgtEl>
@@ -16031,11 +16530,11 @@
                                     </p:set>
                                     <p:animEffect transition="in" filter="fade">
                                       <p:cBhvr>
-                                        <p:cTn id="32" dur="400"/>
+                                        <p:cTn id="26" dur="400"/>
                                         <p:tgtEl>
                                           <p:spTgt spid="8">
                                             <p:txEl>
-                                              <p:pRg st="2" end="2"/>
+                                              <p:pRg st="1" end="1"/>
                                             </p:txEl>
                                           </p:spTgt>
                                         </p:tgtEl>
@@ -16051,26 +16550,26 @@
                     </p:cTn>
                   </p:par>
                   <p:par>
-                    <p:cTn id="33" fill="hold">
+                    <p:cTn id="27" fill="hold">
                       <p:stCondLst>
                         <p:cond delay="indefinite"/>
                       </p:stCondLst>
                       <p:childTnLst>
                         <p:par>
-                          <p:cTn id="34" fill="hold">
+                          <p:cTn id="28" fill="hold">
                             <p:stCondLst>
                               <p:cond delay="0"/>
                             </p:stCondLst>
                             <p:childTnLst>
                               <p:par>
-                                <p:cTn id="35" presetID="10" presetClass="entr" presetSubtype="0" fill="hold" grpId="0" nodeType="clickEffect">
+                                <p:cTn id="29" presetID="10" presetClass="entr" presetSubtype="0" fill="hold" grpId="0" nodeType="clickEffect">
                                   <p:stCondLst>
                                     <p:cond delay="0"/>
                                   </p:stCondLst>
                                   <p:childTnLst>
                                     <p:set>
                                       <p:cBhvr>
-                                        <p:cTn id="36" dur="1" fill="hold">
+                                        <p:cTn id="30" dur="1" fill="hold">
                                           <p:stCondLst>
                                             <p:cond delay="0"/>
                                           </p:stCondLst>
@@ -16078,7 +16577,7 @@
                                         <p:tgtEl>
                                           <p:spTgt spid="8">
                                             <p:txEl>
-                                              <p:pRg st="3" end="3"/>
+                                              <p:pRg st="2" end="2"/>
                                             </p:txEl>
                                           </p:spTgt>
                                         </p:tgtEl>
@@ -16092,11 +16591,11 @@
                                     </p:set>
                                     <p:animEffect transition="in" filter="fade">
                                       <p:cBhvr>
-                                        <p:cTn id="37" dur="400"/>
+                                        <p:cTn id="31" dur="400"/>
                                         <p:tgtEl>
                                           <p:spTgt spid="8">
                                             <p:txEl>
-                                              <p:pRg st="3" end="3"/>
+                                              <p:pRg st="2" end="2"/>
                                             </p:txEl>
                                           </p:spTgt>
                                         </p:tgtEl>
@@ -16112,26 +16611,87 @@
                     </p:cTn>
                   </p:par>
                   <p:par>
-                    <p:cTn id="38" fill="hold">
+                    <p:cTn id="32" fill="hold">
                       <p:stCondLst>
                         <p:cond delay="indefinite"/>
                       </p:stCondLst>
                       <p:childTnLst>
                         <p:par>
-                          <p:cTn id="39" fill="hold">
+                          <p:cTn id="33" fill="hold">
                             <p:stCondLst>
                               <p:cond delay="0"/>
                             </p:stCondLst>
                             <p:childTnLst>
                               <p:par>
-                                <p:cTn id="40" presetID="10" presetClass="entr" presetSubtype="0" fill="hold" grpId="0" nodeType="clickEffect">
+                                <p:cTn id="34" presetID="10" presetClass="entr" presetSubtype="0" fill="hold" grpId="0" nodeType="clickEffect">
                                   <p:stCondLst>
                                     <p:cond delay="0"/>
                                   </p:stCondLst>
                                   <p:childTnLst>
                                     <p:set>
                                       <p:cBhvr>
-                                        <p:cTn id="41" dur="1" fill="hold">
+                                        <p:cTn id="35" dur="1" fill="hold">
+                                          <p:stCondLst>
+                                            <p:cond delay="0"/>
+                                          </p:stCondLst>
+                                        </p:cTn>
+                                        <p:tgtEl>
+                                          <p:spTgt spid="8">
+                                            <p:txEl>
+                                              <p:pRg st="3" end="3"/>
+                                            </p:txEl>
+                                          </p:spTgt>
+                                        </p:tgtEl>
+                                        <p:attrNameLst>
+                                          <p:attrName>style.visibility</p:attrName>
+                                        </p:attrNameLst>
+                                      </p:cBhvr>
+                                      <p:to>
+                                        <p:strVal val="visible"/>
+                                      </p:to>
+                                    </p:set>
+                                    <p:animEffect transition="in" filter="fade">
+                                      <p:cBhvr>
+                                        <p:cTn id="36" dur="400"/>
+                                        <p:tgtEl>
+                                          <p:spTgt spid="8">
+                                            <p:txEl>
+                                              <p:pRg st="3" end="3"/>
+                                            </p:txEl>
+                                          </p:spTgt>
+                                        </p:tgtEl>
+                                      </p:cBhvr>
+                                    </p:animEffect>
+                                  </p:childTnLst>
+                                </p:cTn>
+                              </p:par>
+                            </p:childTnLst>
+                          </p:cTn>
+                        </p:par>
+                      </p:childTnLst>
+                    </p:cTn>
+                  </p:par>
+                  <p:par>
+                    <p:cTn id="37" fill="hold">
+                      <p:stCondLst>
+                        <p:cond delay="indefinite"/>
+                      </p:stCondLst>
+                      <p:childTnLst>
+                        <p:par>
+                          <p:cTn id="38" fill="hold">
+                            <p:stCondLst>
+                              <p:cond delay="0"/>
+                            </p:stCondLst>
+                            <p:childTnLst>
+                              <p:par>
+                                <p:cTn id="39" presetID="10" presetClass="entr" presetSubtype="0" fill="hold" grpId="0" nodeType="clickEffect">
+                                  <p:stCondLst>
+                                    <p:cond delay="0"/>
+                                  </p:stCondLst>
+                                  <p:childTnLst>
+                                    <p:set>
+                                      <p:cBhvr>
+                                        <p:cTn id="40" dur="1" fill="hold">
                                           <p:stCondLst>
                                             <p:cond delay="0"/>
                                           </p:stCondLst>
@@ -16153,7 +16713,7 @@
                                     </p:set>
                                     <p:animEffect transition="in" filter="fade">
                                       <p:cBhvr>
-                                        <p:cTn id="42" dur="400"/>
+                                        <p:cTn id="41" dur="400"/>
                                         <p:tgtEl>
                                           <p:spTgt spid="8">
                                             <p:txEl>
@@ -16763,7 +17323,7 @@
                                 </p:cTn>
                               </p:par>
                               <p:par>
-                                <p:cTn id="14" presetID="53" presetClass="entr" presetSubtype="0" fill="hold" grpId="0" nodeType="withEffect">
+                                <p:cTn id="14" presetID="10" presetClass="entr" presetSubtype="0" fill="hold" grpId="0" nodeType="withEffect">
                                   <p:stCondLst>
                                     <p:cond delay="150"/>
                                   </p:stCondLst>
@@ -16791,77 +17351,6 @@
                                         <p:cTn id="16" dur="600"/>
                                         <p:tgtEl>
                                           <p:spTgt spid="7"/>
-                                        </p:tgtEl>
-                                      </p:cBhvr>
-                                    </p:animEffect>
-                                    <p:animScale>
-                                      <p:cBhvr>
-                                        <p:cTn id="17" dur="600" fill="hold"/>
-                                        <p:tgtEl>
-                                          <p:spTgt spid="7"/>
-                                        </p:tgtEl>
-                                      </p:cBhvr>
-                                      <p:from x="20000" y="20000"/>
-                                      <p:to x="100000" y="100000"/>
-                                    </p:animScale>
-                                  </p:childTnLst>
-                                </p:cTn>
-                              </p:par>
-                            </p:childTnLst>
-                          </p:cTn>
-                        </p:par>
-                      </p:childTnLst>
-                    </p:cTn>
-                  </p:par>
-                  <p:par>
-                    <p:cTn id="18" fill="hold">
-                      <p:stCondLst>
-                        <p:cond delay="indefinite"/>
-                      </p:stCondLst>
-                      <p:childTnLst>
-                        <p:par>
-                          <p:cTn id="19" fill="hold">
-                            <p:stCondLst>
-                              <p:cond delay="0"/>
-                            </p:stCondLst>
-                            <p:childTnLst>
-                              <p:par>
-                                <p:cTn id="20" presetID="10" presetClass="entr" presetSubtype="0" fill="hold" grpId="0" nodeType="clickEffect">
-                                  <p:stCondLst>
-                                    <p:cond delay="0"/>
-                                  </p:stCondLst>
-                                  <p:childTnLst>
-                                    <p:set>
-                                      <p:cBhvr>
-                                        <p:cTn id="21" dur="1" fill="hold">
-                                          <p:stCondLst>
-                                            <p:cond delay="0"/>
-                                          </p:stCondLst>
-                                        </p:cTn>
-                                        <p:tgtEl>
-                                          <p:spTgt spid="8">
-                                            <p:txEl>
-                                              <p:pRg st="0" end="0"/>
-                                            </p:txEl>
-                                          </p:spTgt>
-                                        </p:tgtEl>
-                                        <p:attrNameLst>
-                                          <p:attrName>style.visibility</p:attrName>
-                                        </p:attrNameLst>
-                                      </p:cBhvr>
-                                      <p:to>
-                                        <p:strVal val="visible"/>
-                                      </p:to>
-                                    </p:set>
-                                    <p:animEffect transition="in" filter="fade">
-                                      <p:cBhvr>
-                                        <p:cTn id="22" dur="400"/>
-                                        <p:tgtEl>
-                                          <p:spTgt spid="8">
-                                            <p:txEl>
-                                              <p:pRg st="0" end="0"/>
-                                            </p:txEl>
-                                          </p:spTgt>
                                         </p:tgtEl>
                                       </p:cBhvr>
                                     </p:animEffect>
@@ -16875,26 +17364,26 @@
                     </p:cTn>
                   </p:par>
                   <p:par>
-                    <p:cTn id="23" fill="hold">
+                    <p:cTn id="17" fill="hold">
                       <p:stCondLst>
                         <p:cond delay="indefinite"/>
                       </p:stCondLst>
                       <p:childTnLst>
                         <p:par>
-                          <p:cTn id="24" fill="hold">
+                          <p:cTn id="18" fill="hold">
                             <p:stCondLst>
                               <p:cond delay="0"/>
                             </p:stCondLst>
                             <p:childTnLst>
                               <p:par>
-                                <p:cTn id="25" presetID="10" presetClass="entr" presetSubtype="0" fill="hold" grpId="0" nodeType="clickEffect">
+                                <p:cTn id="19" presetID="10" presetClass="entr" presetSubtype="0" fill="hold" grpId="0" nodeType="clickEffect">
                                   <p:stCondLst>
                                     <p:cond delay="0"/>
                                   </p:stCondLst>
                                   <p:childTnLst>
                                     <p:set>
                                       <p:cBhvr>
-                                        <p:cTn id="26" dur="1" fill="hold">
+                                        <p:cTn id="20" dur="1" fill="hold">
                                           <p:stCondLst>
                                             <p:cond delay="0"/>
                                           </p:stCondLst>
@@ -16902,7 +17391,7 @@
                                         <p:tgtEl>
                                           <p:spTgt spid="8">
                                             <p:txEl>
-                                              <p:pRg st="1" end="1"/>
+                                              <p:pRg st="0" end="0"/>
                                             </p:txEl>
                                           </p:spTgt>
                                         </p:tgtEl>
@@ -16916,11 +17405,11 @@
                                     </p:set>
                                     <p:animEffect transition="in" filter="fade">
                                       <p:cBhvr>
-                                        <p:cTn id="27" dur="400"/>
+                                        <p:cTn id="21" dur="400"/>
                                         <p:tgtEl>
                                           <p:spTgt spid="8">
                                             <p:txEl>
-                                              <p:pRg st="1" end="1"/>
+                                              <p:pRg st="0" end="0"/>
                                             </p:txEl>
                                           </p:spTgt>
                                         </p:tgtEl>
@@ -16936,26 +17425,26 @@
                     </p:cTn>
                   </p:par>
                   <p:par>
-                    <p:cTn id="28" fill="hold">
+                    <p:cTn id="22" fill="hold">
                       <p:stCondLst>
                         <p:cond delay="indefinite"/>
                       </p:stCondLst>
                       <p:childTnLst>
                         <p:par>
-                          <p:cTn id="29" fill="hold">
+                          <p:cTn id="23" fill="hold">
                             <p:stCondLst>
                               <p:cond delay="0"/>
                             </p:stCondLst>
                             <p:childTnLst>
                               <p:par>
-                                <p:cTn id="30" presetID="10" presetClass="entr" presetSubtype="0" fill="hold" grpId="0" nodeType="clickEffect">
+                                <p:cTn id="24" presetID="10" presetClass="entr" presetSubtype="0" fill="hold" grpId="0" nodeType="clickEffect">
                                   <p:stCondLst>
                                     <p:cond delay="0"/>
                                   </p:stCondLst>
                                   <p:childTnLst>
                                     <p:set>
                                       <p:cBhvr>
-                                        <p:cTn id="31" dur="1" fill="hold">
+                                        <p:cTn id="25" dur="1" fill="hold">
                                           <p:stCondLst>
                                             <p:cond delay="0"/>
                                           </p:stCondLst>
@@ -16963,7 +17452,7 @@
                                         <p:tgtEl>
                                           <p:spTgt spid="8">
                                             <p:txEl>
-                                              <p:pRg st="2" end="2"/>
+                                              <p:pRg st="1" end="1"/>
                                             </p:txEl>
                                           </p:spTgt>
                                         </p:tgtEl>
@@ -16977,11 +17466,11 @@
                                     </p:set>
                                     <p:animEffect transition="in" filter="fade">
                                       <p:cBhvr>
-                                        <p:cTn id="32" dur="400"/>
+                                        <p:cTn id="26" dur="400"/>
                                         <p:tgtEl>
                                           <p:spTgt spid="8">
                                             <p:txEl>
-                                              <p:pRg st="2" end="2"/>
+                                              <p:pRg st="1" end="1"/>
                                             </p:txEl>
                                           </p:spTgt>
                                         </p:tgtEl>
@@ -16997,26 +17486,26 @@
                     </p:cTn>
                   </p:par>
                   <p:par>
-                    <p:cTn id="33" fill="hold">
+                    <p:cTn id="27" fill="hold">
                       <p:stCondLst>
                         <p:cond delay="indefinite"/>
                       </p:stCondLst>
                       <p:childTnLst>
                         <p:par>
-                          <p:cTn id="34" fill="hold">
+                          <p:cTn id="28" fill="hold">
                             <p:stCondLst>
                               <p:cond delay="0"/>
                             </p:stCondLst>
                             <p:childTnLst>
                               <p:par>
-                                <p:cTn id="35" presetID="10" presetClass="entr" presetSubtype="0" fill="hold" grpId="0" nodeType="clickEffect">
+                                <p:cTn id="29" presetID="10" presetClass="entr" presetSubtype="0" fill="hold" grpId="0" nodeType="clickEffect">
                                   <p:stCondLst>
                                     <p:cond delay="0"/>
                                   </p:stCondLst>
                                   <p:childTnLst>
                                     <p:set>
                                       <p:cBhvr>
-                                        <p:cTn id="36" dur="1" fill="hold">
+                                        <p:cTn id="30" dur="1" fill="hold">
                                           <p:stCondLst>
                                             <p:cond delay="0"/>
                                           </p:stCondLst>
@@ -17024,7 +17513,7 @@
                                         <p:tgtEl>
                                           <p:spTgt spid="8">
                                             <p:txEl>
-                                              <p:pRg st="3" end="3"/>
+                                              <p:pRg st="2" end="2"/>
                                             </p:txEl>
                                           </p:spTgt>
                                         </p:tgtEl>
@@ -17038,11 +17527,11 @@
                                     </p:set>
                                     <p:animEffect transition="in" filter="fade">
                                       <p:cBhvr>
-                                        <p:cTn id="37" dur="400"/>
+                                        <p:cTn id="31" dur="400"/>
                                         <p:tgtEl>
                                           <p:spTgt spid="8">
                                             <p:txEl>
-                                              <p:pRg st="3" end="3"/>
+                                              <p:pRg st="2" end="2"/>
                                             </p:txEl>
                                           </p:spTgt>
                                         </p:tgtEl>
@@ -17058,26 +17547,87 @@
                     </p:cTn>
                   </p:par>
                   <p:par>
-                    <p:cTn id="38" fill="hold">
+                    <p:cTn id="32" fill="hold">
                       <p:stCondLst>
                         <p:cond delay="indefinite"/>
                       </p:stCondLst>
                       <p:childTnLst>
                         <p:par>
-                          <p:cTn id="39" fill="hold">
+                          <p:cTn id="33" fill="hold">
                             <p:stCondLst>
                               <p:cond delay="0"/>
                             </p:stCondLst>
                             <p:childTnLst>
                               <p:par>
-                                <p:cTn id="40" presetID="10" presetClass="entr" presetSubtype="0" fill="hold" grpId="0" nodeType="clickEffect">
+                                <p:cTn id="34" presetID="10" presetClass="entr" presetSubtype="0" fill="hold" grpId="0" nodeType="clickEffect">
                                   <p:stCondLst>
                                     <p:cond delay="0"/>
                                   </p:stCondLst>
                                   <p:childTnLst>
                                     <p:set>
                                       <p:cBhvr>
-                                        <p:cTn id="41" dur="1" fill="hold">
+                                        <p:cTn id="35" dur="1" fill="hold">
+                                          <p:stCondLst>
+                                            <p:cond delay="0"/>
+                                          </p:stCondLst>
+                                        </p:cTn>
+                                        <p:tgtEl>
+                                          <p:spTgt spid="8">
+                                            <p:txEl>
+                                              <p:pRg st="3" end="3"/>
+                                            </p:txEl>
+                                          </p:spTgt>
+                                        </p:tgtEl>
+                                        <p:attrNameLst>
+                                          <p:attrName>style.visibility</p:attrName>
+                                        </p:attrNameLst>
+                                      </p:cBhvr>
+                                      <p:to>
+                                        <p:strVal val="visible"/>
+                                      </p:to>
+                                    </p:set>
+                                    <p:animEffect transition="in" filter="fade">
+                                      <p:cBhvr>
+                                        <p:cTn id="36" dur="400"/>
+                                        <p:tgtEl>
+                                          <p:spTgt spid="8">
+                                            <p:txEl>
+                                              <p:pRg st="3" end="3"/>
+                                            </p:txEl>
+                                          </p:spTgt>
+                                        </p:tgtEl>
+                                      </p:cBhvr>
+                                    </p:animEffect>
+                                  </p:childTnLst>
+                                </p:cTn>
+                              </p:par>
+                            </p:childTnLst>
+                          </p:cTn>
+                        </p:par>
+                      </p:childTnLst>
+                    </p:cTn>
+                  </p:par>
+                  <p:par>
+                    <p:cTn id="37" fill="hold">
+                      <p:stCondLst>
+                        <p:cond delay="indefinite"/>
+                      </p:stCondLst>
+                      <p:childTnLst>
+                        <p:par>
+                          <p:cTn id="38" fill="hold">
+                            <p:stCondLst>
+                              <p:cond delay="0"/>
+                            </p:stCondLst>
+                            <p:childTnLst>
+                              <p:par>
+                                <p:cTn id="39" presetID="10" presetClass="entr" presetSubtype="0" fill="hold" grpId="0" nodeType="clickEffect">
+                                  <p:stCondLst>
+                                    <p:cond delay="0"/>
+                                  </p:stCondLst>
+                                  <p:childTnLst>
+                                    <p:set>
+                                      <p:cBhvr>
+                                        <p:cTn id="40" dur="1" fill="hold">
                                           <p:stCondLst>
                                             <p:cond delay="0"/>
                                           </p:stCondLst>
@@ -17099,7 +17649,7 @@
                                     </p:set>
                                     <p:animEffect transition="in" filter="fade">
                                       <p:cBhvr>
-                                        <p:cTn id="42" dur="400"/>
+                                        <p:cTn id="41" dur="400"/>
                                         <p:tgtEl>
                                           <p:spTgt spid="8">
                                             <p:txEl>
@@ -17709,7 +18259,7 @@
                                 </p:cTn>
                               </p:par>
                               <p:par>
-                                <p:cTn id="14" presetID="53" presetClass="entr" presetSubtype="0" fill="hold" grpId="0" nodeType="withEffect">
+                                <p:cTn id="14" presetID="10" presetClass="entr" presetSubtype="0" fill="hold" grpId="0" nodeType="withEffect">
                                   <p:stCondLst>
                                     <p:cond delay="150"/>
                                   </p:stCondLst>
@@ -17737,77 +18287,6 @@
                                         <p:cTn id="16" dur="600"/>
                                         <p:tgtEl>
                                           <p:spTgt spid="7"/>
-                                        </p:tgtEl>
-                                      </p:cBhvr>
-                                    </p:animEffect>
-                                    <p:animScale>
-                                      <p:cBhvr>
-                                        <p:cTn id="17" dur="600" fill="hold"/>
-                                        <p:tgtEl>
-                                          <p:spTgt spid="7"/>
-                                        </p:tgtEl>
-                                      </p:cBhvr>
-                                      <p:from x="20000" y="20000"/>
-                                      <p:to x="100000" y="100000"/>
-                                    </p:animScale>
-                                  </p:childTnLst>
-                                </p:cTn>
-                              </p:par>
-                            </p:childTnLst>
-                          </p:cTn>
-                        </p:par>
-                      </p:childTnLst>
-                    </p:cTn>
-                  </p:par>
-                  <p:par>
-                    <p:cTn id="18" fill="hold">
-                      <p:stCondLst>
-                        <p:cond delay="indefinite"/>
-                      </p:stCondLst>
-                      <p:childTnLst>
-                        <p:par>
-                          <p:cTn id="19" fill="hold">
-                            <p:stCondLst>
-                              <p:cond delay="0"/>
-                            </p:stCondLst>
-                            <p:childTnLst>
-                              <p:par>
-                                <p:cTn id="20" presetID="10" presetClass="entr" presetSubtype="0" fill="hold" grpId="0" nodeType="clickEffect">
-                                  <p:stCondLst>
-                                    <p:cond delay="0"/>
-                                  </p:stCondLst>
-                                  <p:childTnLst>
-                                    <p:set>
-                                      <p:cBhvr>
-                                        <p:cTn id="21" dur="1" fill="hold">
-                                          <p:stCondLst>
-                                            <p:cond delay="0"/>
-                                          </p:stCondLst>
-                                        </p:cTn>
-                                        <p:tgtEl>
-                                          <p:spTgt spid="8">
-                                            <p:txEl>
-                                              <p:pRg st="0" end="0"/>
-                                            </p:txEl>
-                                          </p:spTgt>
-                                        </p:tgtEl>
-                                        <p:attrNameLst>
-                                          <p:attrName>style.visibility</p:attrName>
-                                        </p:attrNameLst>
-                                      </p:cBhvr>
-                                      <p:to>
-                                        <p:strVal val="visible"/>
-                                      </p:to>
-                                    </p:set>
-                                    <p:animEffect transition="in" filter="fade">
-                                      <p:cBhvr>
-                                        <p:cTn id="22" dur="400"/>
-                                        <p:tgtEl>
-                                          <p:spTgt spid="8">
-                                            <p:txEl>
-                                              <p:pRg st="0" end="0"/>
-                                            </p:txEl>
-                                          </p:spTgt>
                                         </p:tgtEl>
                                       </p:cBhvr>
                                     </p:animEffect>
@@ -17821,26 +18300,26 @@
                     </p:cTn>
                   </p:par>
                   <p:par>
-                    <p:cTn id="23" fill="hold">
+                    <p:cTn id="17" fill="hold">
                       <p:stCondLst>
                         <p:cond delay="indefinite"/>
                       </p:stCondLst>
                       <p:childTnLst>
                         <p:par>
-                          <p:cTn id="24" fill="hold">
+                          <p:cTn id="18" fill="hold">
                             <p:stCondLst>
                               <p:cond delay="0"/>
                             </p:stCondLst>
                             <p:childTnLst>
                               <p:par>
-                                <p:cTn id="25" presetID="10" presetClass="entr" presetSubtype="0" fill="hold" grpId="0" nodeType="clickEffect">
+                                <p:cTn id="19" presetID="10" presetClass="entr" presetSubtype="0" fill="hold" grpId="0" nodeType="clickEffect">
                                   <p:stCondLst>
                                     <p:cond delay="0"/>
                                   </p:stCondLst>
                                   <p:childTnLst>
                                     <p:set>
                                       <p:cBhvr>
-                                        <p:cTn id="26" dur="1" fill="hold">
+                                        <p:cTn id="20" dur="1" fill="hold">
                                           <p:stCondLst>
                                             <p:cond delay="0"/>
                                           </p:stCondLst>
@@ -17848,7 +18327,7 @@
                                         <p:tgtEl>
                                           <p:spTgt spid="8">
                                             <p:txEl>
-                                              <p:pRg st="1" end="1"/>
+                                              <p:pRg st="0" end="0"/>
                                             </p:txEl>
                                           </p:spTgt>
                                         </p:tgtEl>
@@ -17862,11 +18341,11 @@
                                     </p:set>
                                     <p:animEffect transition="in" filter="fade">
                                       <p:cBhvr>
-                                        <p:cTn id="27" dur="400"/>
+                                        <p:cTn id="21" dur="400"/>
                                         <p:tgtEl>
                                           <p:spTgt spid="8">
                                             <p:txEl>
-                                              <p:pRg st="1" end="1"/>
+                                              <p:pRg st="0" end="0"/>
                                             </p:txEl>
                                           </p:spTgt>
                                         </p:tgtEl>
@@ -17882,26 +18361,26 @@
                     </p:cTn>
                   </p:par>
                   <p:par>
-                    <p:cTn id="28" fill="hold">
+                    <p:cTn id="22" fill="hold">
                       <p:stCondLst>
                         <p:cond delay="indefinite"/>
                       </p:stCondLst>
                       <p:childTnLst>
                         <p:par>
-                          <p:cTn id="29" fill="hold">
+                          <p:cTn id="23" fill="hold">
                             <p:stCondLst>
                               <p:cond delay="0"/>
                             </p:stCondLst>
                             <p:childTnLst>
                               <p:par>
-                                <p:cTn id="30" presetID="10" presetClass="entr" presetSubtype="0" fill="hold" grpId="0" nodeType="clickEffect">
+                                <p:cTn id="24" presetID="10" presetClass="entr" presetSubtype="0" fill="hold" grpId="0" nodeType="clickEffect">
                                   <p:stCondLst>
                                     <p:cond delay="0"/>
                                   </p:stCondLst>
                                   <p:childTnLst>
                                     <p:set>
                                       <p:cBhvr>
-                                        <p:cTn id="31" dur="1" fill="hold">
+                                        <p:cTn id="25" dur="1" fill="hold">
                                           <p:stCondLst>
                                             <p:cond delay="0"/>
                                           </p:stCondLst>
@@ -17909,7 +18388,7 @@
                                         <p:tgtEl>
                                           <p:spTgt spid="8">
                                             <p:txEl>
-                                              <p:pRg st="2" end="2"/>
+                                              <p:pRg st="1" end="1"/>
                                             </p:txEl>
                                           </p:spTgt>
                                         </p:tgtEl>
@@ -17923,11 +18402,11 @@
                                     </p:set>
                                     <p:animEffect transition="in" filter="fade">
                                       <p:cBhvr>
-                                        <p:cTn id="32" dur="400"/>
+                                        <p:cTn id="26" dur="400"/>
                                         <p:tgtEl>
                                           <p:spTgt spid="8">
                                             <p:txEl>
-                                              <p:pRg st="2" end="2"/>
+                                              <p:pRg st="1" end="1"/>
                                             </p:txEl>
                                           </p:spTgt>
                                         </p:tgtEl>
@@ -17943,26 +18422,26 @@
                     </p:cTn>
                   </p:par>
                   <p:par>
-                    <p:cTn id="33" fill="hold">
+                    <p:cTn id="27" fill="hold">
                       <p:stCondLst>
                         <p:cond delay="indefinite"/>
                       </p:stCondLst>
                       <p:childTnLst>
                         <p:par>
-                          <p:cTn id="34" fill="hold">
+                          <p:cTn id="28" fill="hold">
                             <p:stCondLst>
                               <p:cond delay="0"/>
                             </p:stCondLst>
                             <p:childTnLst>
                               <p:par>
-                                <p:cTn id="35" presetID="10" presetClass="entr" presetSubtype="0" fill="hold" grpId="0" nodeType="clickEffect">
+                                <p:cTn id="29" presetID="10" presetClass="entr" presetSubtype="0" fill="hold" grpId="0" nodeType="clickEffect">
                                   <p:stCondLst>
                                     <p:cond delay="0"/>
                                   </p:stCondLst>
                                   <p:childTnLst>
                                     <p:set>
                                       <p:cBhvr>
-                                        <p:cTn id="36" dur="1" fill="hold">
+                                        <p:cTn id="30" dur="1" fill="hold">
                                           <p:stCondLst>
                                             <p:cond delay="0"/>
                                           </p:stCondLst>
@@ -17970,7 +18449,7 @@
                                         <p:tgtEl>
                                           <p:spTgt spid="8">
                                             <p:txEl>
-                                              <p:pRg st="3" end="3"/>
+                                              <p:pRg st="2" end="2"/>
                                             </p:txEl>
                                           </p:spTgt>
                                         </p:tgtEl>
@@ -17984,11 +18463,11 @@
                                     </p:set>
                                     <p:animEffect transition="in" filter="fade">
                                       <p:cBhvr>
-                                        <p:cTn id="37" dur="400"/>
+                                        <p:cTn id="31" dur="400"/>
                                         <p:tgtEl>
                                           <p:spTgt spid="8">
                                             <p:txEl>
-                                              <p:pRg st="3" end="3"/>
+                                              <p:pRg st="2" end="2"/>
                                             </p:txEl>
                                           </p:spTgt>
                                         </p:tgtEl>
@@ -18004,26 +18483,87 @@
                     </p:cTn>
                   </p:par>
                   <p:par>
-                    <p:cTn id="38" fill="hold">
+                    <p:cTn id="32" fill="hold">
                       <p:stCondLst>
                         <p:cond delay="indefinite"/>
                       </p:stCondLst>
                       <p:childTnLst>
                         <p:par>
-                          <p:cTn id="39" fill="hold">
+                          <p:cTn id="33" fill="hold">
                             <p:stCondLst>
                               <p:cond delay="0"/>
                             </p:stCondLst>
                             <p:childTnLst>
                               <p:par>
-                                <p:cTn id="40" presetID="10" presetClass="entr" presetSubtype="0" fill="hold" grpId="0" nodeType="clickEffect">
+                                <p:cTn id="34" presetID="10" presetClass="entr" presetSubtype="0" fill="hold" grpId="0" nodeType="clickEffect">
                                   <p:stCondLst>
                                     <p:cond delay="0"/>
                                   </p:stCondLst>
                                   <p:childTnLst>
                                     <p:set>
                                       <p:cBhvr>
-                                        <p:cTn id="41" dur="1" fill="hold">
+                                        <p:cTn id="35" dur="1" fill="hold">
+                                          <p:stCondLst>
+                                            <p:cond delay="0"/>
+                                          </p:stCondLst>
+                                        </p:cTn>
+                                        <p:tgtEl>
+                                          <p:spTgt spid="8">
+                                            <p:txEl>
+                                              <p:pRg st="3" end="3"/>
+                                            </p:txEl>
+                                          </p:spTgt>
+                                        </p:tgtEl>
+                                        <p:attrNameLst>
+                                          <p:attrName>style.visibility</p:attrName>
+                                        </p:attrNameLst>
+                                      </p:cBhvr>
+                                      <p:to>
+                                        <p:strVal val="visible"/>
+                                      </p:to>
+                                    </p:set>
+                                    <p:animEffect transition="in" filter="fade">
+                                      <p:cBhvr>
+                                        <p:cTn id="36" dur="400"/>
+                                        <p:tgtEl>
+                                          <p:spTgt spid="8">
+                                            <p:txEl>
+                                              <p:pRg st="3" end="3"/>
+                                            </p:txEl>
+                                          </p:spTgt>
+                                        </p:tgtEl>
+                                      </p:cBhvr>
+                                    </p:animEffect>
+                                  </p:childTnLst>
+                                </p:cTn>
+                              </p:par>
+                            </p:childTnLst>
+                          </p:cTn>
+                        </p:par>
+                      </p:childTnLst>
+                    </p:cTn>
+                  </p:par>
+                  <p:par>
+                    <p:cTn id="37" fill="hold">
+                      <p:stCondLst>
+                        <p:cond delay="indefinite"/>
+                      </p:stCondLst>
+                      <p:childTnLst>
+                        <p:par>
+                          <p:cTn id="38" fill="hold">
+                            <p:stCondLst>
+                              <p:cond delay="0"/>
+                            </p:stCondLst>
+                            <p:childTnLst>
+                              <p:par>
+                                <p:cTn id="39" presetID="10" presetClass="entr" presetSubtype="0" fill="hold" grpId="0" nodeType="clickEffect">
+                                  <p:stCondLst>
+                                    <p:cond delay="0"/>
+                                  </p:stCondLst>
+                                  <p:childTnLst>
+                                    <p:set>
+                                      <p:cBhvr>
+                                        <p:cTn id="40" dur="1" fill="hold">
                                           <p:stCondLst>
                                             <p:cond delay="0"/>
                                           </p:stCondLst>
@@ -18045,7 +18585,7 @@
                                     </p:set>
                                     <p:animEffect transition="in" filter="fade">
                                       <p:cBhvr>
-                                        <p:cTn id="42" dur="400"/>
+                                        <p:cTn id="41" dur="400"/>
                                         <p:tgtEl>
                                           <p:spTgt spid="8">
                                             <p:txEl>
@@ -18689,7 +19229,7 @@
                                 </p:cTn>
                               </p:par>
                               <p:par>
-                                <p:cTn id="14" presetID="53" presetClass="entr" presetSubtype="0" fill="hold" grpId="0" nodeType="withEffect">
+                                <p:cTn id="14" presetID="10" presetClass="entr" presetSubtype="0" fill="hold" grpId="0" nodeType="withEffect">
                                   <p:stCondLst>
                                     <p:cond delay="150"/>
                                   </p:stCondLst>
@@ -18717,77 +19257,6 @@
                                         <p:cTn id="16" dur="600"/>
                                         <p:tgtEl>
                                           <p:spTgt spid="7"/>
-                                        </p:tgtEl>
-                                      </p:cBhvr>
-                                    </p:animEffect>
-                                    <p:animScale>
-                                      <p:cBhvr>
-                                        <p:cTn id="17" dur="600" fill="hold"/>
-                                        <p:tgtEl>
-                                          <p:spTgt spid="7"/>
-                                        </p:tgtEl>
-                                      </p:cBhvr>
-                                      <p:from x="20000" y="20000"/>
-                                      <p:to x="100000" y="100000"/>
-                                    </p:animScale>
-                                  </p:childTnLst>
-                                </p:cTn>
-                              </p:par>
-                            </p:childTnLst>
-                          </p:cTn>
-                        </p:par>
-                      </p:childTnLst>
-                    </p:cTn>
-                  </p:par>
-                  <p:par>
-                    <p:cTn id="18" fill="hold">
-                      <p:stCondLst>
-                        <p:cond delay="indefinite"/>
-                      </p:stCondLst>
-                      <p:childTnLst>
-                        <p:par>
-                          <p:cTn id="19" fill="hold">
-                            <p:stCondLst>
-                              <p:cond delay="0"/>
-                            </p:stCondLst>
-                            <p:childTnLst>
-                              <p:par>
-                                <p:cTn id="20" presetID="10" presetClass="entr" presetSubtype="0" fill="hold" grpId="0" nodeType="clickEffect">
-                                  <p:stCondLst>
-                                    <p:cond delay="0"/>
-                                  </p:stCondLst>
-                                  <p:childTnLst>
-                                    <p:set>
-                                      <p:cBhvr>
-                                        <p:cTn id="21" dur="1" fill="hold">
-                                          <p:stCondLst>
-                                            <p:cond delay="0"/>
-                                          </p:stCondLst>
-                                        </p:cTn>
-                                        <p:tgtEl>
-                                          <p:spTgt spid="8">
-                                            <p:txEl>
-                                              <p:pRg st="0" end="0"/>
-                                            </p:txEl>
-                                          </p:spTgt>
-                                        </p:tgtEl>
-                                        <p:attrNameLst>
-                                          <p:attrName>style.visibility</p:attrName>
-                                        </p:attrNameLst>
-                                      </p:cBhvr>
-                                      <p:to>
-                                        <p:strVal val="visible"/>
-                                      </p:to>
-                                    </p:set>
-                                    <p:animEffect transition="in" filter="fade">
-                                      <p:cBhvr>
-                                        <p:cTn id="22" dur="400"/>
-                                        <p:tgtEl>
-                                          <p:spTgt spid="8">
-                                            <p:txEl>
-                                              <p:pRg st="0" end="0"/>
-                                            </p:txEl>
-                                          </p:spTgt>
                                         </p:tgtEl>
                                       </p:cBhvr>
                                     </p:animEffect>
@@ -18801,26 +19270,26 @@
                     </p:cTn>
                   </p:par>
                   <p:par>
-                    <p:cTn id="23" fill="hold">
+                    <p:cTn id="17" fill="hold">
                       <p:stCondLst>
                         <p:cond delay="indefinite"/>
                       </p:stCondLst>
                       <p:childTnLst>
                         <p:par>
-                          <p:cTn id="24" fill="hold">
+                          <p:cTn id="18" fill="hold">
                             <p:stCondLst>
                               <p:cond delay="0"/>
                             </p:stCondLst>
                             <p:childTnLst>
                               <p:par>
-                                <p:cTn id="25" presetID="10" presetClass="entr" presetSubtype="0" fill="hold" grpId="0" nodeType="clickEffect">
+                                <p:cTn id="19" presetID="10" presetClass="entr" presetSubtype="0" fill="hold" grpId="0" nodeType="clickEffect">
                                   <p:stCondLst>
                                     <p:cond delay="0"/>
                                   </p:stCondLst>
                                   <p:childTnLst>
                                     <p:set>
                                       <p:cBhvr>
-                                        <p:cTn id="26" dur="1" fill="hold">
+                                        <p:cTn id="20" dur="1" fill="hold">
                                           <p:stCondLst>
                                             <p:cond delay="0"/>
                                           </p:stCondLst>
@@ -18828,7 +19297,7 @@
                                         <p:tgtEl>
                                           <p:spTgt spid="8">
                                             <p:txEl>
-                                              <p:pRg st="1" end="1"/>
+                                              <p:pRg st="0" end="0"/>
                                             </p:txEl>
                                           </p:spTgt>
                                         </p:tgtEl>
@@ -18842,11 +19311,11 @@
                                     </p:set>
                                     <p:animEffect transition="in" filter="fade">
                                       <p:cBhvr>
-                                        <p:cTn id="27" dur="400"/>
+                                        <p:cTn id="21" dur="400"/>
                                         <p:tgtEl>
                                           <p:spTgt spid="8">
                                             <p:txEl>
-                                              <p:pRg st="1" end="1"/>
+                                              <p:pRg st="0" end="0"/>
                                             </p:txEl>
                                           </p:spTgt>
                                         </p:tgtEl>
@@ -18862,26 +19331,26 @@
                     </p:cTn>
                   </p:par>
                   <p:par>
-                    <p:cTn id="28" fill="hold">
+                    <p:cTn id="22" fill="hold">
                       <p:stCondLst>
                         <p:cond delay="indefinite"/>
                       </p:stCondLst>
                       <p:childTnLst>
                         <p:par>
-                          <p:cTn id="29" fill="hold">
+                          <p:cTn id="23" fill="hold">
                             <p:stCondLst>
                               <p:cond delay="0"/>
                             </p:stCondLst>
                             <p:childTnLst>
                               <p:par>
-                                <p:cTn id="30" presetID="10" presetClass="entr" presetSubtype="0" fill="hold" grpId="0" nodeType="clickEffect">
+                                <p:cTn id="24" presetID="10" presetClass="entr" presetSubtype="0" fill="hold" grpId="0" nodeType="clickEffect">
                                   <p:stCondLst>
                                     <p:cond delay="0"/>
                                   </p:stCondLst>
                                   <p:childTnLst>
                                     <p:set>
                                       <p:cBhvr>
-                                        <p:cTn id="31" dur="1" fill="hold">
+                                        <p:cTn id="25" dur="1" fill="hold">
                                           <p:stCondLst>
                                             <p:cond delay="0"/>
                                           </p:stCondLst>
@@ -18889,7 +19358,7 @@
                                         <p:tgtEl>
                                           <p:spTgt spid="8">
                                             <p:txEl>
-                                              <p:pRg st="2" end="2"/>
+                                              <p:pRg st="1" end="1"/>
                                             </p:txEl>
                                           </p:spTgt>
                                         </p:tgtEl>
@@ -18903,11 +19372,11 @@
                                     </p:set>
                                     <p:animEffect transition="in" filter="fade">
                                       <p:cBhvr>
-                                        <p:cTn id="32" dur="400"/>
+                                        <p:cTn id="26" dur="400"/>
                                         <p:tgtEl>
                                           <p:spTgt spid="8">
                                             <p:txEl>
-                                              <p:pRg st="2" end="2"/>
+                                              <p:pRg st="1" end="1"/>
                                             </p:txEl>
                                           </p:spTgt>
                                         </p:tgtEl>
@@ -18923,26 +19392,26 @@
                     </p:cTn>
                   </p:par>
                   <p:par>
-                    <p:cTn id="33" fill="hold">
+                    <p:cTn id="27" fill="hold">
                       <p:stCondLst>
                         <p:cond delay="indefinite"/>
                       </p:stCondLst>
                       <p:childTnLst>
                         <p:par>
-                          <p:cTn id="34" fill="hold">
+                          <p:cTn id="28" fill="hold">
                             <p:stCondLst>
                               <p:cond delay="0"/>
                             </p:stCondLst>
                             <p:childTnLst>
                               <p:par>
-                                <p:cTn id="35" presetID="10" presetClass="entr" presetSubtype="0" fill="hold" grpId="0" nodeType="clickEffect">
+                                <p:cTn id="29" presetID="10" presetClass="entr" presetSubtype="0" fill="hold" grpId="0" nodeType="clickEffect">
                                   <p:stCondLst>
                                     <p:cond delay="0"/>
                                   </p:stCondLst>
                                   <p:childTnLst>
                                     <p:set>
                                       <p:cBhvr>
-                                        <p:cTn id="36" dur="1" fill="hold">
+                                        <p:cTn id="30" dur="1" fill="hold">
                                           <p:stCondLst>
                                             <p:cond delay="0"/>
                                           </p:stCondLst>
@@ -18950,7 +19419,7 @@
                                         <p:tgtEl>
                                           <p:spTgt spid="8">
                                             <p:txEl>
-                                              <p:pRg st="3" end="3"/>
+                                              <p:pRg st="2" end="2"/>
                                             </p:txEl>
                                           </p:spTgt>
                                         </p:tgtEl>
@@ -18964,11 +19433,11 @@
                                     </p:set>
                                     <p:animEffect transition="in" filter="fade">
                                       <p:cBhvr>
-                                        <p:cTn id="37" dur="400"/>
+                                        <p:cTn id="31" dur="400"/>
                                         <p:tgtEl>
                                           <p:spTgt spid="8">
                                             <p:txEl>
-                                              <p:pRg st="3" end="3"/>
+                                              <p:pRg st="2" end="2"/>
                                             </p:txEl>
                                           </p:spTgt>
                                         </p:tgtEl>
@@ -18984,26 +19453,26 @@
                     </p:cTn>
                   </p:par>
                   <p:par>
-                    <p:cTn id="38" fill="hold">
+                    <p:cTn id="32" fill="hold">
                       <p:stCondLst>
                         <p:cond delay="indefinite"/>
                       </p:stCondLst>
                       <p:childTnLst>
                         <p:par>
-                          <p:cTn id="39" fill="hold">
+                          <p:cTn id="33" fill="hold">
                             <p:stCondLst>
                               <p:cond delay="0"/>
                             </p:stCondLst>
                             <p:childTnLst>
                               <p:par>
-                                <p:cTn id="40" presetID="10" presetClass="entr" presetSubtype="0" fill="hold" grpId="0" nodeType="clickEffect">
+                                <p:cTn id="34" presetID="10" presetClass="entr" presetSubtype="0" fill="hold" grpId="0" nodeType="clickEffect">
                                   <p:stCondLst>
                                     <p:cond delay="0"/>
                                   </p:stCondLst>
                                   <p:childTnLst>
                                     <p:set>
                                       <p:cBhvr>
-                                        <p:cTn id="41" dur="1" fill="hold">
+                                        <p:cTn id="35" dur="1" fill="hold">
                                           <p:stCondLst>
                                             <p:cond delay="0"/>
                                           </p:stCondLst>
@@ -19011,7 +19480,7 @@
                                         <p:tgtEl>
                                           <p:spTgt spid="8">
                                             <p:txEl>
-                                              <p:pRg st="4" end="4"/>
+                                              <p:pRg st="3" end="3"/>
                                             </p:txEl>
                                           </p:spTgt>
                                         </p:tgtEl>
@@ -19025,11 +19494,11 @@
                                     </p:set>
                                     <p:animEffect transition="in" filter="fade">
                                       <p:cBhvr>
-                                        <p:cTn id="42" dur="400"/>
+                                        <p:cTn id="36" dur="400"/>
                                         <p:tgtEl>
                                           <p:spTgt spid="8">
                                             <p:txEl>
-                                              <p:pRg st="4" end="4"/>
+                                              <p:pRg st="3" end="3"/>
                                             </p:txEl>
                                           </p:spTgt>
                                         </p:tgtEl>
@@ -19045,26 +19514,87 @@
                     </p:cTn>
                   </p:par>
                   <p:par>
-                    <p:cTn id="43" fill="hold">
+                    <p:cTn id="37" fill="hold">
                       <p:stCondLst>
                         <p:cond delay="indefinite"/>
                       </p:stCondLst>
                       <p:childTnLst>
                         <p:par>
-                          <p:cTn id="44" fill="hold">
+                          <p:cTn id="38" fill="hold">
                             <p:stCondLst>
                               <p:cond delay="0"/>
                             </p:stCondLst>
                             <p:childTnLst>
                               <p:par>
-                                <p:cTn id="45" presetID="10" presetClass="entr" presetSubtype="0" fill="hold" grpId="0" nodeType="clickEffect">
+                                <p:cTn id="39" presetID="10" presetClass="entr" presetSubtype="0" fill="hold" grpId="0" nodeType="clickEffect">
                                   <p:stCondLst>
                                     <p:cond delay="0"/>
                                   </p:stCondLst>
                                   <p:childTnLst>
                                     <p:set>
                                       <p:cBhvr>
-                                        <p:cTn id="46" dur="1" fill="hold">
+                                        <p:cTn id="40" dur="1" fill="hold">
+                                          <p:stCondLst>
+                                            <p:cond delay="0"/>
+                                          </p:stCondLst>
+                                        </p:cTn>
+                                        <p:tgtEl>
+                                          <p:spTgt spid="8">
+                                            <p:txEl>
+                                              <p:pRg st="4" end="4"/>
+                                            </p:txEl>
+                                          </p:spTgt>
+                                        </p:tgtEl>
+                                        <p:attrNameLst>
+                                          <p:attrName>style.visibility</p:attrName>
+                                        </p:attrNameLst>
+                                      </p:cBhvr>
+                                      <p:to>
+                                        <p:strVal val="visible"/>
+                                      </p:to>
+                                    </p:set>
+                                    <p:animEffect transition="in" filter="fade">
+                                      <p:cBhvr>
+                                        <p:cTn id="41" dur="400"/>
+                                        <p:tgtEl>
+                                          <p:spTgt spid="8">
+                                            <p:txEl>
+                                              <p:pRg st="4" end="4"/>
+                                            </p:txEl>
+                                          </p:spTgt>
+                                        </p:tgtEl>
+                                      </p:cBhvr>
+                                    </p:animEffect>
+                                  </p:childTnLst>
+                                </p:cTn>
+                              </p:par>
+                            </p:childTnLst>
+                          </p:cTn>
+                        </p:par>
+                      </p:childTnLst>
+                    </p:cTn>
+                  </p:par>
+                  <p:par>
+                    <p:cTn id="42" fill="hold">
+                      <p:stCondLst>
+                        <p:cond delay="indefinite"/>
+                      </p:stCondLst>
+                      <p:childTnLst>
+                        <p:par>
+                          <p:cTn id="43" fill="hold">
+                            <p:stCondLst>
+                              <p:cond delay="0"/>
+                            </p:stCondLst>
+                            <p:childTnLst>
+                              <p:par>
+                                <p:cTn id="44" presetID="10" presetClass="entr" presetSubtype="0" fill="hold" grpId="0" nodeType="clickEffect">
+                                  <p:stCondLst>
+                                    <p:cond delay="0"/>
+                                  </p:stCondLst>
+                                  <p:childTnLst>
+                                    <p:set>
+                                      <p:cBhvr>
+                                        <p:cTn id="45" dur="1" fill="hold">
                                           <p:stCondLst>
                                             <p:cond delay="0"/>
                                           </p:stCondLst>
@@ -19086,7 +19616,7 @@
                                     </p:set>
                                     <p:animEffect transition="in" filter="fade">
                                       <p:cBhvr>
-                                        <p:cTn id="47" dur="400"/>
+                                        <p:cTn id="46" dur="400"/>
                                         <p:tgtEl>
                                           <p:spTgt spid="8">
                                             <p:txEl>
@@ -19569,6 +20099,78 @@
           </a:p>
         </p:txBody>
       </p:sp>
+      <p:pic>
+        <p:nvPicPr>
+          <p:cNvPr id="9" name="Picture 8" descr="arrow.png"/>
+          <p:cNvPicPr>
+            <a:picLocks noChangeAspect="1"/>
+          </p:cNvPicPr>
+          <p:nvPr/>
+        </p:nvPicPr>
+        <p:blipFill>
+          <a:blip r:embed="rId3"/>
+          <a:stretch>
+            <a:fillRect/>
+          </a:stretch>
+        </p:blipFill>
+        <p:spPr>
+          <a:xfrm>
+            <a:off x="-1371600" y="5806440"/>
+            <a:ext cx="1234440" cy="182880"/>
+          </a:xfrm>
+          <a:prstGeom prst="rect">
+            <a:avLst/>
+          </a:prstGeom>
+        </p:spPr>
+      </p:pic>
+      <p:pic>
+        <p:nvPicPr>
+          <p:cNvPr id="10" name="Picture 9" descr="arrow.png"/>
+          <p:cNvPicPr>
+            <a:picLocks noChangeAspect="1"/>
+          </p:cNvPicPr>
+          <p:nvPr/>
+        </p:nvPicPr>
+        <p:blipFill>
+          <a:blip r:embed="rId3"/>
+          <a:stretch>
+            <a:fillRect/>
+          </a:stretch>
+        </p:blipFill>
+        <p:spPr>
+          <a:xfrm>
+            <a:off x="-1371600" y="6053328"/>
+            <a:ext cx="1234440" cy="182880"/>
+          </a:xfrm>
+          <a:prstGeom prst="rect">
+            <a:avLst/>
+          </a:prstGeom>
+        </p:spPr>
+      </p:pic>
+      <p:pic>
+        <p:nvPicPr>
+          <p:cNvPr id="11" name="Picture 10" descr="arrow.png"/>
+          <p:cNvPicPr>
+            <a:picLocks noChangeAspect="1"/>
+          </p:cNvPicPr>
+          <p:nvPr/>
+        </p:nvPicPr>
+        <p:blipFill>
+          <a:blip r:embed="rId3"/>
+          <a:stretch>
+            <a:fillRect/>
+          </a:stretch>
+        </p:blipFill>
+        <p:spPr>
+          <a:xfrm>
+            <a:off x="-1371600" y="6291072"/>
+            <a:ext cx="1234440" cy="182880"/>
+          </a:xfrm>
+          <a:prstGeom prst="rect">
+            <a:avLst/>
+          </a:prstGeom>
+        </p:spPr>
+      </p:pic>
     </p:spTree>
   </p:cSld>
   <p:clrMapOvr>
@@ -19696,7 +20298,7 @@
                                 </p:cTn>
                               </p:par>
                               <p:par>
-                                <p:cTn id="14" presetID="53" presetClass="entr" presetSubtype="0" fill="hold" grpId="0" nodeType="withEffect">
+                                <p:cTn id="14" presetID="10" presetClass="entr" presetSubtype="0" fill="hold" grpId="0" nodeType="withEffect">
                                   <p:stCondLst>
                                     <p:cond delay="150"/>
                                   </p:stCondLst>
@@ -19724,77 +20326,6 @@
                                         <p:cTn id="16" dur="600"/>
                                         <p:tgtEl>
                                           <p:spTgt spid="7"/>
-                                        </p:tgtEl>
-                                      </p:cBhvr>
-                                    </p:animEffect>
-                                    <p:animScale>
-                                      <p:cBhvr>
-                                        <p:cTn id="17" dur="600" fill="hold"/>
-                                        <p:tgtEl>
-                                          <p:spTgt spid="7"/>
-                                        </p:tgtEl>
-                                      </p:cBhvr>
-                                      <p:from x="20000" y="20000"/>
-                                      <p:to x="100000" y="100000"/>
-                                    </p:animScale>
-                                  </p:childTnLst>
-                                </p:cTn>
-                              </p:par>
-                            </p:childTnLst>
-                          </p:cTn>
-                        </p:par>
-                      </p:childTnLst>
-                    </p:cTn>
-                  </p:par>
-                  <p:par>
-                    <p:cTn id="18" fill="hold">
-                      <p:stCondLst>
-                        <p:cond delay="indefinite"/>
-                      </p:stCondLst>
-                      <p:childTnLst>
-                        <p:par>
-                          <p:cTn id="19" fill="hold">
-                            <p:stCondLst>
-                              <p:cond delay="0"/>
-                            </p:stCondLst>
-                            <p:childTnLst>
-                              <p:par>
-                                <p:cTn id="20" presetID="10" presetClass="entr" presetSubtype="0" fill="hold" grpId="0" nodeType="clickEffect">
-                                  <p:stCondLst>
-                                    <p:cond delay="0"/>
-                                  </p:stCondLst>
-                                  <p:childTnLst>
-                                    <p:set>
-                                      <p:cBhvr>
-                                        <p:cTn id="21" dur="1" fill="hold">
-                                          <p:stCondLst>
-                                            <p:cond delay="0"/>
-                                          </p:stCondLst>
-                                        </p:cTn>
-                                        <p:tgtEl>
-                                          <p:spTgt spid="8">
-                                            <p:txEl>
-                                              <p:pRg st="0" end="0"/>
-                                            </p:txEl>
-                                          </p:spTgt>
-                                        </p:tgtEl>
-                                        <p:attrNameLst>
-                                          <p:attrName>style.visibility</p:attrName>
-                                        </p:attrNameLst>
-                                      </p:cBhvr>
-                                      <p:to>
-                                        <p:strVal val="visible"/>
-                                      </p:to>
-                                    </p:set>
-                                    <p:animEffect transition="in" filter="fade">
-                                      <p:cBhvr>
-                                        <p:cTn id="22" dur="400"/>
-                                        <p:tgtEl>
-                                          <p:spTgt spid="8">
-                                            <p:txEl>
-                                              <p:pRg st="0" end="0"/>
-                                            </p:txEl>
-                                          </p:spTgt>
                                         </p:tgtEl>
                                       </p:cBhvr>
                                     </p:animEffect>
@@ -19808,26 +20339,26 @@
                     </p:cTn>
                   </p:par>
                   <p:par>
-                    <p:cTn id="23" fill="hold">
+                    <p:cTn id="17" fill="hold">
                       <p:stCondLst>
                         <p:cond delay="indefinite"/>
                       </p:stCondLst>
                       <p:childTnLst>
                         <p:par>
-                          <p:cTn id="24" fill="hold">
+                          <p:cTn id="18" fill="hold">
                             <p:stCondLst>
                               <p:cond delay="0"/>
                             </p:stCondLst>
                             <p:childTnLst>
                               <p:par>
-                                <p:cTn id="25" presetID="10" presetClass="entr" presetSubtype="0" fill="hold" grpId="0" nodeType="clickEffect">
+                                <p:cTn id="19" presetID="10" presetClass="entr" presetSubtype="0" fill="hold" grpId="0" nodeType="clickEffect">
                                   <p:stCondLst>
                                     <p:cond delay="0"/>
                                   </p:stCondLst>
                                   <p:childTnLst>
                                     <p:set>
                                       <p:cBhvr>
-                                        <p:cTn id="26" dur="1" fill="hold">
+                                        <p:cTn id="20" dur="1" fill="hold">
                                           <p:stCondLst>
                                             <p:cond delay="0"/>
                                           </p:stCondLst>
@@ -19835,7 +20366,7 @@
                                         <p:tgtEl>
                                           <p:spTgt spid="8">
                                             <p:txEl>
-                                              <p:pRg st="1" end="1"/>
+                                              <p:pRg st="0" end="0"/>
                                             </p:txEl>
                                           </p:spTgt>
                                         </p:tgtEl>
@@ -19849,11 +20380,11 @@
                                     </p:set>
                                     <p:animEffect transition="in" filter="fade">
                                       <p:cBhvr>
-                                        <p:cTn id="27" dur="400"/>
+                                        <p:cTn id="21" dur="400"/>
                                         <p:tgtEl>
                                           <p:spTgt spid="8">
                                             <p:txEl>
-                                              <p:pRg st="1" end="1"/>
+                                              <p:pRg st="0" end="0"/>
                                             </p:txEl>
                                           </p:spTgt>
                                         </p:tgtEl>
@@ -19869,26 +20400,26 @@
                     </p:cTn>
                   </p:par>
                   <p:par>
-                    <p:cTn id="28" fill="hold">
+                    <p:cTn id="22" fill="hold">
                       <p:stCondLst>
                         <p:cond delay="indefinite"/>
                       </p:stCondLst>
                       <p:childTnLst>
                         <p:par>
-                          <p:cTn id="29" fill="hold">
+                          <p:cTn id="23" fill="hold">
                             <p:stCondLst>
                               <p:cond delay="0"/>
                             </p:stCondLst>
                             <p:childTnLst>
                               <p:par>
-                                <p:cTn id="30" presetID="10" presetClass="entr" presetSubtype="0" fill="hold" grpId="0" nodeType="clickEffect">
+                                <p:cTn id="24" presetID="10" presetClass="entr" presetSubtype="0" fill="hold" grpId="0" nodeType="clickEffect">
                                   <p:stCondLst>
                                     <p:cond delay="0"/>
                                   </p:stCondLst>
                                   <p:childTnLst>
                                     <p:set>
                                       <p:cBhvr>
-                                        <p:cTn id="31" dur="1" fill="hold">
+                                        <p:cTn id="25" dur="1" fill="hold">
                                           <p:stCondLst>
                                             <p:cond delay="0"/>
                                           </p:stCondLst>
@@ -19896,7 +20427,7 @@
                                         <p:tgtEl>
                                           <p:spTgt spid="8">
                                             <p:txEl>
-                                              <p:pRg st="2" end="2"/>
+                                              <p:pRg st="1" end="1"/>
                                             </p:txEl>
                                           </p:spTgt>
                                         </p:tgtEl>
@@ -19910,11 +20441,11 @@
                                     </p:set>
                                     <p:animEffect transition="in" filter="fade">
                                       <p:cBhvr>
-                                        <p:cTn id="32" dur="400"/>
+                                        <p:cTn id="26" dur="400"/>
                                         <p:tgtEl>
                                           <p:spTgt spid="8">
                                             <p:txEl>
-                                              <p:pRg st="2" end="2"/>
+                                              <p:pRg st="1" end="1"/>
                                             </p:txEl>
                                           </p:spTgt>
                                         </p:tgtEl>
@@ -19930,26 +20461,26 @@
                     </p:cTn>
                   </p:par>
                   <p:par>
-                    <p:cTn id="33" fill="hold">
+                    <p:cTn id="27" fill="hold">
                       <p:stCondLst>
                         <p:cond delay="indefinite"/>
                       </p:stCondLst>
                       <p:childTnLst>
                         <p:par>
-                          <p:cTn id="34" fill="hold">
+                          <p:cTn id="28" fill="hold">
                             <p:stCondLst>
                               <p:cond delay="0"/>
                             </p:stCondLst>
                             <p:childTnLst>
                               <p:par>
-                                <p:cTn id="35" presetID="10" presetClass="entr" presetSubtype="0" fill="hold" grpId="0" nodeType="clickEffect">
+                                <p:cTn id="29" presetID="10" presetClass="entr" presetSubtype="0" fill="hold" grpId="0" nodeType="clickEffect">
                                   <p:stCondLst>
                                     <p:cond delay="0"/>
                                   </p:stCondLst>
                                   <p:childTnLst>
                                     <p:set>
                                       <p:cBhvr>
-                                        <p:cTn id="36" dur="1" fill="hold">
+                                        <p:cTn id="30" dur="1" fill="hold">
                                           <p:stCondLst>
                                             <p:cond delay="0"/>
                                           </p:stCondLst>
@@ -19957,7 +20488,7 @@
                                         <p:tgtEl>
                                           <p:spTgt spid="8">
                                             <p:txEl>
-                                              <p:pRg st="3" end="3"/>
+                                              <p:pRg st="2" end="2"/>
                                             </p:txEl>
                                           </p:spTgt>
                                         </p:tgtEl>
@@ -19971,11 +20502,11 @@
                                     </p:set>
                                     <p:animEffect transition="in" filter="fade">
                                       <p:cBhvr>
-                                        <p:cTn id="37" dur="400"/>
+                                        <p:cTn id="31" dur="400"/>
                                         <p:tgtEl>
                                           <p:spTgt spid="8">
                                             <p:txEl>
-                                              <p:pRg st="3" end="3"/>
+                                              <p:pRg st="2" end="2"/>
                                             </p:txEl>
                                           </p:spTgt>
                                         </p:tgtEl>
@@ -19991,26 +20522,87 @@
                     </p:cTn>
                   </p:par>
                   <p:par>
-                    <p:cTn id="38" fill="hold">
+                    <p:cTn id="32" fill="hold">
                       <p:stCondLst>
                         <p:cond delay="indefinite"/>
                       </p:stCondLst>
                       <p:childTnLst>
                         <p:par>
-                          <p:cTn id="39" fill="hold">
+                          <p:cTn id="33" fill="hold">
                             <p:stCondLst>
                               <p:cond delay="0"/>
                             </p:stCondLst>
                             <p:childTnLst>
                               <p:par>
-                                <p:cTn id="40" presetID="10" presetClass="entr" presetSubtype="0" fill="hold" grpId="0" nodeType="clickEffect">
+                                <p:cTn id="34" presetID="10" presetClass="entr" presetSubtype="0" fill="hold" grpId="0" nodeType="clickEffect">
                                   <p:stCondLst>
                                     <p:cond delay="0"/>
                                   </p:stCondLst>
                                   <p:childTnLst>
                                     <p:set>
                                       <p:cBhvr>
-                                        <p:cTn id="41" dur="1" fill="hold">
+                                        <p:cTn id="35" dur="1" fill="hold">
+                                          <p:stCondLst>
+                                            <p:cond delay="0"/>
+                                          </p:stCondLst>
+                                        </p:cTn>
+                                        <p:tgtEl>
+                                          <p:spTgt spid="8">
+                                            <p:txEl>
+                                              <p:pRg st="3" end="3"/>
+                                            </p:txEl>
+                                          </p:spTgt>
+                                        </p:tgtEl>
+                                        <p:attrNameLst>
+                                          <p:attrName>style.visibility</p:attrName>
+                                        </p:attrNameLst>
+                                      </p:cBhvr>
+                                      <p:to>
+                                        <p:strVal val="visible"/>
+                                      </p:to>
+                                    </p:set>
+                                    <p:animEffect transition="in" filter="fade">
+                                      <p:cBhvr>
+                                        <p:cTn id="36" dur="400"/>
+                                        <p:tgtEl>
+                                          <p:spTgt spid="8">
+                                            <p:txEl>
+                                              <p:pRg st="3" end="3"/>
+                                            </p:txEl>
+                                          </p:spTgt>
+                                        </p:tgtEl>
+                                      </p:cBhvr>
+                                    </p:animEffect>
+                                  </p:childTnLst>
+                                </p:cTn>
+                              </p:par>
+                            </p:childTnLst>
+                          </p:cTn>
+                        </p:par>
+                      </p:childTnLst>
+                    </p:cTn>
+                  </p:par>
+                  <p:par>
+                    <p:cTn id="37" fill="hold">
+                      <p:stCondLst>
+                        <p:cond delay="indefinite"/>
+                      </p:stCondLst>
+                      <p:childTnLst>
+                        <p:par>
+                          <p:cTn id="38" fill="hold">
+                            <p:stCondLst>
+                              <p:cond delay="0"/>
+                            </p:stCondLst>
+                            <p:childTnLst>
+                              <p:par>
+                                <p:cTn id="39" presetID="10" presetClass="entr" presetSubtype="0" fill="hold" grpId="0" nodeType="clickEffect">
+                                  <p:stCondLst>
+                                    <p:cond delay="0"/>
+                                  </p:stCondLst>
+                                  <p:childTnLst>
+                                    <p:set>
+                                      <p:cBhvr>
+                                        <p:cTn id="40" dur="1" fill="hold">
                                           <p:stCondLst>
                                             <p:cond delay="0"/>
                                           </p:stCondLst>
@@ -20032,7 +20624,7 @@
                                     </p:set>
                                     <p:animEffect transition="in" filter="fade">
                                       <p:cBhvr>
-                                        <p:cTn id="42" dur="400"/>
+                                        <p:cTn id="41" dur="400"/>
                                         <p:tgtEl>
                                           <p:spTgt spid="8">
                                             <p:txEl>
@@ -20042,6 +20634,123 @@
                                         </p:tgtEl>
                                       </p:cBhvr>
                                     </p:animEffect>
+                                  </p:childTnLst>
+                                </p:cTn>
+                              </p:par>
+                            </p:childTnLst>
+                          </p:cTn>
+                        </p:par>
+                      </p:childTnLst>
+                    </p:cTn>
+                  </p:par>
+                  <p:par>
+                    <p:cTn id="42" fill="hold">
+                      <p:stCondLst>
+                        <p:cond delay="0"/>
+                      </p:stCondLst>
+                      <p:childTnLst>
+                        <p:par>
+                          <p:cTn id="43" fill="hold">
+                            <p:stCondLst>
+                              <p:cond delay="0"/>
+                            </p:stCondLst>
+                            <p:childTnLst>
+                              <p:par>
+                                <p:cTn id="44" presetID="0" presetClass="path" presetSubtype="0" fill="hold" grpId="0" nodeType="afterEffect">
+                                  <p:stCondLst>
+                                    <p:cond delay="0"/>
+                                  </p:stCondLst>
+                                  <p:childTnLst>
+                                    <p:animMotion origin="layout" path="M 0 0 L 1.3 0.012 E" pathEditMode="relative" ptsTypes="">
+                                      <p:cBhvr>
+                                        <p:cTn id="45" dur="2100" repeatCount="indefinite" fill="hold"/>
+                                        <p:tgtEl>
+                                          <p:spTgt spid="9"/>
+                                        </p:tgtEl>
+                                        <p:attrNameLst>
+                                          <p:attrName>ppt_x</p:attrName>
+                                          <p:attrName>ppt_y</p:attrName>
+                                        </p:attrNameLst>
+                                      </p:cBhvr>
+                                    </p:animMotion>
+                                  </p:childTnLst>
+                                </p:cTn>
+                              </p:par>
+                            </p:childTnLst>
+                          </p:cTn>
+                        </p:par>
+                      </p:childTnLst>
+                    </p:cTn>
+                  </p:par>
+                  <p:par>
+                    <p:cTn id="46" fill="hold">
+                      <p:stCondLst>
+                        <p:cond delay="0"/>
+                      </p:stCondLst>
+                      <p:childTnLst>
+                        <p:par>
+                          <p:cTn id="47" fill="hold">
+                            <p:stCondLst>
+                              <p:cond delay="0"/>
+                            </p:stCondLst>
+                            <p:childTnLst>
+                              <p:par>
+                                <p:cTn id="48" presetID="0" presetClass="path" presetSubtype="0" fill="hold" grpId="0" nodeType="afterEffect">
+                                  <p:stCondLst>
+                                    <p:cond delay="450"/>
+                                  </p:stCondLst>
+                                  <p:childTnLst>
+                                    <p:animMotion origin="layout" path="M 0 0 L 1.3 0.012 E" pathEditMode="relative" ptsTypes="">
+                                      <p:cBhvr>
+                                        <p:cTn id="49" dur="1700" repeatCount="indefinite" fill="hold"/>
+                                        <p:tgtEl>
+                                          <p:spTgt spid="10"/>
+                                        </p:tgtEl>
+                                        <p:attrNameLst>
+                                          <p:attrName>ppt_x</p:attrName>
+                                          <p:attrName>ppt_y</p:attrName>
+                                        </p:attrNameLst>
+                                      </p:cBhvr>
+                                    </p:animMotion>
+                                  </p:childTnLst>
+                                </p:cTn>
+                              </p:par>
+                            </p:childTnLst>
+                          </p:cTn>
+                        </p:par>
+                      </p:childTnLst>
+                    </p:cTn>
+                  </p:par>
+                  <p:par>
+                    <p:cTn id="50" fill="hold">
+                      <p:stCondLst>
+                        <p:cond delay="0"/>
+                      </p:stCondLst>
+                      <p:childTnLst>
+                        <p:par>
+                          <p:cTn id="51" fill="hold">
+                            <p:stCondLst>
+                              <p:cond delay="0"/>
+                            </p:stCondLst>
+                            <p:childTnLst>
+                              <p:par>
+                                <p:cTn id="52" presetID="0" presetClass="path" presetSubtype="0" fill="hold" grpId="0" nodeType="afterEffect">
+                                  <p:stCondLst>
+                                    <p:cond delay="900"/>
+                                  </p:stCondLst>
+                                  <p:childTnLst>
+                                    <p:animMotion origin="layout" path="M 0 0 L 1.3 0.012 E" pathEditMode="relative" ptsTypes="">
+                                      <p:cBhvr>
+                                        <p:cTn id="53" dur="1900" repeatCount="indefinite" fill="hold"/>
+                                        <p:tgtEl>
+                                          <p:spTgt spid="11"/>
+                                        </p:tgtEl>
+                                        <p:attrNameLst>
+                                          <p:attrName>ppt_x</p:attrName>
+                                          <p:attrName>ppt_y</p:attrName>
+                                        </p:attrNameLst>
+                                      </p:cBhvr>
+                                    </p:animMotion>
                                   </p:childTnLst>
                                 </p:cTn>
                               </p:par>

</xml_diff>